<commit_message>
Make the topic conflict stand out on slide 1
Block 01 is now titled 충돌을 조율해 주제를 정하다 and shows the clash
as [참신성] VS [구현 가능성] with outward arrows, with the deadline as a
clear tag above. HTML, PDF, previews and PPTX rebuilt.

Co-Authored-By: Claude Opus 5.5 <noreply@anthropic.com>
Claude-Session: https://claude.ai/code/session_01D2YY6No1o1YF3BX8eJSF6k
</commit_message>
<xml_diff>
--- a/hec-pt/pptx/landscape.pptx
+++ b/hec-pt/pptx/landscape.pptx
@@ -1210,7 +1210,7 @@
         <p:spPr>
           <a:xfrm>
             <a:off x="762000" y="2086124"/>
-            <a:ext cx="2466479" cy="243780"/>
+            <a:ext cx="2639120" cy="243780"/>
           </a:xfrm>
           <a:prstGeom prst="rect">
             <a:avLst/>
@@ -1299,8 +1299,8 @@
         </p:blipFill>
         <p:spPr>
           <a:xfrm>
-            <a:off x="897467" y="2906514"/>
-            <a:ext cx="2853267" cy="965200"/>
+            <a:off x="768350" y="2972131"/>
+            <a:ext cx="3111500" cy="861483"/>
           </a:xfrm>
           <a:prstGeom prst="rect">
             <a:avLst/>
@@ -1309,14 +1309,14 @@
       </p:pic>
       <p:sp>
         <p:nvSpPr>
-          <p:cNvPr id="14" name="p1-at p1-op"/>
-          <p:cNvSpPr/>
-          <p:nvPr/>
-        </p:nvSpPr>
-        <p:spPr>
-          <a:xfrm>
-            <a:off x="901948" y="2798564"/>
-            <a:ext cx="710704" cy="317500"/>
+          <p:cNvPr id="14" name="p1-at p1-tag"/>
+          <p:cNvSpPr/>
+          <p:nvPr/>
+        </p:nvSpPr>
+        <p:spPr>
+          <a:xfrm>
+            <a:off x="1453704" y="2576314"/>
+            <a:ext cx="1740793" cy="215900"/>
           </a:xfrm>
           <a:prstGeom prst="roundRect">
             <a:avLst>
@@ -1324,73 +1324,14 @@
             </a:avLst>
           </a:prstGeom>
           <a:solidFill>
-            <a:srgbClr val="FFFFFF"/>
-          </a:solidFill>
-          <a:ln w="12700">
-            <a:solidFill>
-              <a:srgbClr val="C3CEDD"/>
-            </a:solidFill>
-            <a:prstDash val="solid"/>
-          </a:ln>
-        </p:spPr>
-      </p:sp>
-      <p:sp>
-        <p:nvSpPr>
-          <p:cNvPr id="15" name="p1-at p1-op"/>
-          <p:cNvSpPr/>
-          <p:nvPr/>
-        </p:nvSpPr>
-        <p:spPr>
-          <a:xfrm>
-            <a:off x="2889250" y="2798564"/>
-            <a:ext cx="1003300" cy="317500"/>
-          </a:xfrm>
-          <a:prstGeom prst="roundRect">
-            <a:avLst>
-              <a:gd name="adj" fmla="val 50000"/>
-            </a:avLst>
-          </a:prstGeom>
-          <a:solidFill>
-            <a:srgbClr val="FFFFFF"/>
-          </a:solidFill>
-          <a:ln w="12700">
-            <a:solidFill>
-              <a:srgbClr val="C3CEDD"/>
-            </a:solidFill>
-            <a:prstDash val="solid"/>
-          </a:ln>
-        </p:spPr>
-      </p:sp>
-      <p:sp>
-        <p:nvSpPr>
-          <p:cNvPr id="16" name="p1-at p1-crit"/>
-          <p:cNvSpPr/>
-          <p:nvPr/>
-        </p:nvSpPr>
-        <p:spPr>
-          <a:xfrm>
-            <a:off x="1741636" y="3865364"/>
-            <a:ext cx="1164927" cy="304800"/>
-          </a:xfrm>
-          <a:prstGeom prst="roundRect">
-            <a:avLst>
-              <a:gd name="adj" fmla="val 50000"/>
-            </a:avLst>
-          </a:prstGeom>
-          <a:solidFill>
-            <a:srgbClr val="FFFFFF"/>
-          </a:solidFill>
-          <a:ln w="12700">
-            <a:solidFill>
-              <a:srgbClr val="004B8D"/>
-            </a:solidFill>
-            <a:prstDash val="solid"/>
-          </a:ln>
+            <a:srgbClr val="D8E0EB"/>
+          </a:solidFill>
+          <a:ln/>
         </p:spPr>
       </p:sp>
       <p:pic>
         <p:nvPicPr>
-          <p:cNvPr id="17" name="p1-down" descr="p1-down">    </p:cNvPr>
+          <p:cNvPr id="15" name="svg" descr="svg">    </p:cNvPr>
           <p:cNvPicPr>
             <a:picLocks noChangeAspect="1"/>
           </p:cNvPicPr>
@@ -1404,8 +1345,8 @@
         </p:blipFill>
         <p:spPr>
           <a:xfrm>
-            <a:off x="2260600" y="4183922"/>
-            <a:ext cx="127000" cy="190500"/>
+            <a:off x="1534137" y="2629231"/>
+            <a:ext cx="116417" cy="114300"/>
           </a:xfrm>
           <a:prstGeom prst="rect">
             <a:avLst/>
@@ -1414,93 +1355,153 @@
       </p:pic>
       <p:sp>
         <p:nvSpPr>
-          <p:cNvPr id="18" name="p1-topic"/>
-          <p:cNvSpPr/>
-          <p:nvPr/>
-        </p:nvSpPr>
-        <p:spPr>
-          <a:xfrm>
-            <a:off x="762000" y="4386064"/>
-            <a:ext cx="3124200" cy="1174750"/>
+          <p:cNvPr id="16" name="p1-op"/>
+          <p:cNvSpPr/>
+          <p:nvPr/>
+        </p:nvSpPr>
+        <p:spPr>
+          <a:xfrm>
+            <a:off x="971550" y="2868414"/>
+            <a:ext cx="1104900" cy="330200"/>
           </a:xfrm>
           <a:prstGeom prst="roundRect">
             <a:avLst>
-              <a:gd name="adj" fmla="val 9730"/>
+              <a:gd name="adj" fmla="val 50000"/>
             </a:avLst>
           </a:prstGeom>
           <a:solidFill>
-            <a:srgbClr val="0B2147"/>
-          </a:solidFill>
-          <a:ln/>
-        </p:spPr>
-      </p:sp>
-      <p:sp>
-        <p:nvSpPr>
-          <p:cNvPr id="19" name="p1-blk p1-b2"/>
-          <p:cNvSpPr/>
-          <p:nvPr/>
-        </p:nvSpPr>
-        <p:spPr>
-          <a:xfrm>
-            <a:off x="4254500" y="2436614"/>
-            <a:ext cx="4191000" cy="3263900"/>
+            <a:srgbClr val="FFFFFF"/>
+          </a:solidFill>
+          <a:ln w="12700">
+            <a:solidFill>
+              <a:srgbClr val="C3CEDD"/>
+            </a:solidFill>
+            <a:prstDash val="solid"/>
+          </a:ln>
+        </p:spPr>
+      </p:sp>
+      <p:sp>
+        <p:nvSpPr>
+          <p:cNvPr id="17" name="i"/>
+          <p:cNvSpPr/>
+          <p:nvPr/>
+        </p:nvSpPr>
+        <p:spPr>
+          <a:xfrm>
+            <a:off x="1241127" y="2989064"/>
+            <a:ext cx="88900" cy="88900"/>
+          </a:xfrm>
+          <a:prstGeom prst="ellipse">
+            <a:avLst/>
+          </a:prstGeom>
+          <a:solidFill>
+            <a:srgbClr val="00A94F"/>
+          </a:solidFill>
+          <a:ln/>
+        </p:spPr>
+      </p:sp>
+      <p:sp>
+        <p:nvSpPr>
+          <p:cNvPr id="18" name="p1-op"/>
+          <p:cNvSpPr/>
+          <p:nvPr/>
+        </p:nvSpPr>
+        <p:spPr>
+          <a:xfrm>
+            <a:off x="2571750" y="2868414"/>
+            <a:ext cx="1104900" cy="330200"/>
           </a:xfrm>
           <a:prstGeom prst="roundRect">
             <a:avLst>
-              <a:gd name="adj" fmla="val 4280"/>
+              <a:gd name="adj" fmla="val 50000"/>
             </a:avLst>
           </a:prstGeom>
           <a:solidFill>
-            <a:srgbClr val="EEF4FC"/>
-          </a:solidFill>
-          <a:ln/>
-        </p:spPr>
-      </p:sp>
-      <p:sp>
-        <p:nvSpPr>
-          <p:cNvPr id="20" name="p1-lead"/>
-          <p:cNvSpPr/>
-          <p:nvPr/>
-        </p:nvSpPr>
-        <p:spPr>
-          <a:xfrm>
-            <a:off x="5061148" y="2576314"/>
-            <a:ext cx="2577604" cy="863402"/>
+            <a:srgbClr val="FFFFFF"/>
+          </a:solidFill>
+          <a:ln w="12700">
+            <a:solidFill>
+              <a:srgbClr val="C3CEDD"/>
+            </a:solidFill>
+            <a:prstDash val="solid"/>
+          </a:ln>
+        </p:spPr>
+      </p:sp>
+      <p:sp>
+        <p:nvSpPr>
+          <p:cNvPr id="19" name="i"/>
+          <p:cNvSpPr/>
+          <p:nvPr/>
+        </p:nvSpPr>
+        <p:spPr>
+          <a:xfrm>
+            <a:off x="2682776" y="2989064"/>
+            <a:ext cx="88900" cy="88900"/>
+          </a:xfrm>
+          <a:prstGeom prst="ellipse">
+            <a:avLst/>
+          </a:prstGeom>
+          <a:solidFill>
+            <a:srgbClr val="00A94F"/>
+          </a:solidFill>
+          <a:ln/>
+        </p:spPr>
+      </p:sp>
+      <p:sp>
+        <p:nvSpPr>
+          <p:cNvPr id="20" name="p1-vs"/>
+          <p:cNvSpPr/>
+          <p:nvPr/>
+        </p:nvSpPr>
+        <p:spPr>
+          <a:xfrm>
+            <a:off x="2155825" y="2865239"/>
+            <a:ext cx="336550" cy="336550"/>
+          </a:xfrm>
+          <a:prstGeom prst="ellipse">
+            <a:avLst/>
+          </a:prstGeom>
+          <a:solidFill>
+            <a:srgbClr val="0B2147"/>
+          </a:solidFill>
+          <a:ln w="19050">
+            <a:solidFill>
+              <a:srgbClr val="FFFFFF"/>
+            </a:solidFill>
+            <a:prstDash val="solid"/>
+          </a:ln>
+        </p:spPr>
+      </p:sp>
+      <p:sp>
+        <p:nvSpPr>
+          <p:cNvPr id="21" name="p1-at p1-crit"/>
+          <p:cNvSpPr/>
+          <p:nvPr/>
+        </p:nvSpPr>
+        <p:spPr>
+          <a:xfrm>
+            <a:off x="1741636" y="3827264"/>
+            <a:ext cx="1164927" cy="304800"/>
           </a:xfrm>
           <a:prstGeom prst="roundRect">
             <a:avLst>
-              <a:gd name="adj" fmla="val 13238"/>
+              <a:gd name="adj" fmla="val 50000"/>
             </a:avLst>
           </a:prstGeom>
           <a:solidFill>
-            <a:srgbClr val="0B2147"/>
-          </a:solidFill>
-          <a:ln/>
-        </p:spPr>
-      </p:sp>
-      <p:sp>
-        <p:nvSpPr>
-          <p:cNvPr id="21" name="p1-av"/>
-          <p:cNvSpPr/>
-          <p:nvPr/>
-        </p:nvSpPr>
-        <p:spPr>
-          <a:xfrm>
-            <a:off x="6022578" y="2745184"/>
-            <a:ext cx="88900" cy="88900"/>
-          </a:xfrm>
-          <a:prstGeom prst="ellipse">
-            <a:avLst/>
-          </a:prstGeom>
-          <a:solidFill>
-            <a:srgbClr val="00A94F"/>
-          </a:solidFill>
-          <a:ln/>
+            <a:srgbClr val="FFFFFF"/>
+          </a:solidFill>
+          <a:ln w="12700">
+            <a:solidFill>
+              <a:srgbClr val="004B8D"/>
+            </a:solidFill>
+            <a:prstDash val="solid"/>
+          </a:ln>
         </p:spPr>
       </p:sp>
       <p:pic>
         <p:nvPicPr>
-          <p:cNvPr id="22" name="p1-tree" descr="p1-tree">    </p:cNvPr>
+          <p:cNvPr id="22" name="p1-down" descr="p1-down">    </p:cNvPr>
           <p:cNvPicPr>
             <a:picLocks noChangeAspect="1"/>
           </p:cNvPicPr>
@@ -1514,8 +1515,8 @@
         </p:blipFill>
         <p:spPr>
           <a:xfrm>
-            <a:off x="4997450" y="3431249"/>
-            <a:ext cx="2705100" cy="541867"/>
+            <a:off x="2260600" y="4164872"/>
+            <a:ext cx="127000" cy="190500"/>
           </a:xfrm>
           <a:prstGeom prst="rect">
             <a:avLst/>
@@ -1524,134 +1525,79 @@
       </p:pic>
       <p:sp>
         <p:nvSpPr>
-          <p:cNvPr id="23" name="p1-mem"/>
-          <p:cNvSpPr/>
-          <p:nvPr/>
-        </p:nvSpPr>
-        <p:spPr>
-          <a:xfrm>
-            <a:off x="4387850" y="3966766"/>
-            <a:ext cx="1240334" cy="1030982"/>
+          <p:cNvPr id="23" name="p1-topic"/>
+          <p:cNvSpPr/>
+          <p:nvPr/>
+        </p:nvSpPr>
+        <p:spPr>
+          <a:xfrm>
+            <a:off x="762000" y="4386064"/>
+            <a:ext cx="3124200" cy="1174750"/>
           </a:xfrm>
           <a:prstGeom prst="roundRect">
             <a:avLst>
-              <a:gd name="adj" fmla="val 10471"/>
+              <a:gd name="adj" fmla="val 9730"/>
             </a:avLst>
           </a:prstGeom>
           <a:solidFill>
-            <a:srgbClr val="FFFFFF"/>
-          </a:solidFill>
-          <a:ln w="12700">
-            <a:solidFill>
-              <a:srgbClr val="D8E0EB"/>
-            </a:solidFill>
-            <a:prstDash val="solid"/>
-          </a:ln>
-        </p:spPr>
-      </p:sp>
-      <p:sp>
-        <p:nvSpPr>
-          <p:cNvPr id="24" name="p1-av"/>
-          <p:cNvSpPr/>
-          <p:nvPr/>
-        </p:nvSpPr>
-        <p:spPr>
-          <a:xfrm>
-            <a:off x="4727873" y="4116586"/>
-            <a:ext cx="88900" cy="88900"/>
-          </a:xfrm>
-          <a:prstGeom prst="ellipse">
-            <a:avLst/>
-          </a:prstGeom>
-          <a:solidFill>
-            <a:srgbClr val="00A94F"/>
-          </a:solidFill>
-          <a:ln/>
-        </p:spPr>
-      </p:sp>
-      <p:sp>
-        <p:nvSpPr>
-          <p:cNvPr id="25" name="p1-mem"/>
-          <p:cNvSpPr/>
-          <p:nvPr/>
-        </p:nvSpPr>
-        <p:spPr>
-          <a:xfrm>
-            <a:off x="5729784" y="3966766"/>
-            <a:ext cx="1240334" cy="1030982"/>
+            <a:srgbClr val="0B2147"/>
+          </a:solidFill>
+          <a:ln/>
+        </p:spPr>
+      </p:sp>
+      <p:sp>
+        <p:nvSpPr>
+          <p:cNvPr id="24" name="p1-blk p1-b2"/>
+          <p:cNvSpPr/>
+          <p:nvPr/>
+        </p:nvSpPr>
+        <p:spPr>
+          <a:xfrm>
+            <a:off x="4254500" y="2436614"/>
+            <a:ext cx="4191000" cy="3263900"/>
           </a:xfrm>
           <a:prstGeom prst="roundRect">
             <a:avLst>
-              <a:gd name="adj" fmla="val 10471"/>
+              <a:gd name="adj" fmla="val 4280"/>
             </a:avLst>
           </a:prstGeom>
           <a:solidFill>
-            <a:srgbClr val="FFFFFF"/>
-          </a:solidFill>
-          <a:ln w="12700">
-            <a:solidFill>
-              <a:srgbClr val="D8E0EB"/>
-            </a:solidFill>
-            <a:prstDash val="solid"/>
-          </a:ln>
-        </p:spPr>
-      </p:sp>
-      <p:sp>
-        <p:nvSpPr>
-          <p:cNvPr id="26" name="p1-av"/>
-          <p:cNvSpPr/>
-          <p:nvPr/>
-        </p:nvSpPr>
-        <p:spPr>
-          <a:xfrm>
-            <a:off x="6069905" y="4116586"/>
-            <a:ext cx="88900" cy="88900"/>
-          </a:xfrm>
-          <a:prstGeom prst="ellipse">
-            <a:avLst/>
-          </a:prstGeom>
-          <a:solidFill>
-            <a:srgbClr val="00A94F"/>
-          </a:solidFill>
-          <a:ln/>
-        </p:spPr>
-      </p:sp>
-      <p:sp>
-        <p:nvSpPr>
-          <p:cNvPr id="27" name="p1-mem"/>
-          <p:cNvSpPr/>
-          <p:nvPr/>
-        </p:nvSpPr>
-        <p:spPr>
-          <a:xfrm>
-            <a:off x="7071717" y="3966766"/>
-            <a:ext cx="1240334" cy="1030982"/>
+            <a:srgbClr val="EEF4FC"/>
+          </a:solidFill>
+          <a:ln/>
+        </p:spPr>
+      </p:sp>
+      <p:sp>
+        <p:nvSpPr>
+          <p:cNvPr id="25" name="p1-lead"/>
+          <p:cNvSpPr/>
+          <p:nvPr/>
+        </p:nvSpPr>
+        <p:spPr>
+          <a:xfrm>
+            <a:off x="5061148" y="2576314"/>
+            <a:ext cx="2577604" cy="863402"/>
           </a:xfrm>
           <a:prstGeom prst="roundRect">
             <a:avLst>
-              <a:gd name="adj" fmla="val 10471"/>
+              <a:gd name="adj" fmla="val 13238"/>
             </a:avLst>
           </a:prstGeom>
           <a:solidFill>
-            <a:srgbClr val="FFFFFF"/>
-          </a:solidFill>
-          <a:ln w="12700">
-            <a:solidFill>
-              <a:srgbClr val="D8E0EB"/>
-            </a:solidFill>
-            <a:prstDash val="solid"/>
-          </a:ln>
-        </p:spPr>
-      </p:sp>
-      <p:sp>
-        <p:nvSpPr>
-          <p:cNvPr id="28" name="p1-av"/>
-          <p:cNvSpPr/>
-          <p:nvPr/>
-        </p:nvSpPr>
-        <p:spPr>
-          <a:xfrm>
-            <a:off x="7414419" y="4116586"/>
+            <a:srgbClr val="0B2147"/>
+          </a:solidFill>
+          <a:ln/>
+        </p:spPr>
+      </p:sp>
+      <p:sp>
+        <p:nvSpPr>
+          <p:cNvPr id="26" name="p1-av"/>
+          <p:cNvSpPr/>
+          <p:nvPr/>
+        </p:nvSpPr>
+        <p:spPr>
+          <a:xfrm>
+            <a:off x="6022578" y="2745184"/>
             <a:ext cx="88900" cy="88900"/>
           </a:xfrm>
           <a:prstGeom prst="ellipse">
@@ -1665,7 +1611,7 @@
       </p:sp>
       <p:pic>
         <p:nvPicPr>
-          <p:cNvPr id="29" name="svg" descr="svg">    </p:cNvPr>
+          <p:cNvPr id="27" name="p1-tree" descr="p1-tree">    </p:cNvPr>
           <p:cNvPicPr>
             <a:picLocks noChangeAspect="1"/>
           </p:cNvPicPr>
@@ -1679,8 +1625,8 @@
         </p:blipFill>
         <p:spPr>
           <a:xfrm>
-            <a:off x="4997450" y="5004098"/>
-            <a:ext cx="2705100" cy="226483"/>
+            <a:off x="4997450" y="3431249"/>
+            <a:ext cx="2705100" cy="541867"/>
           </a:xfrm>
           <a:prstGeom prst="rect">
             <a:avLst/>
@@ -1689,29 +1635,148 @@
       </p:pic>
       <p:sp>
         <p:nvSpPr>
-          <p:cNvPr id="30" name="p1-share"/>
-          <p:cNvSpPr/>
-          <p:nvPr/>
-        </p:nvSpPr>
-        <p:spPr>
-          <a:xfrm>
-            <a:off x="4381500" y="5230614"/>
-            <a:ext cx="3937000" cy="330200"/>
+          <p:cNvPr id="28" name="p1-mem"/>
+          <p:cNvSpPr/>
+          <p:nvPr/>
+        </p:nvSpPr>
+        <p:spPr>
+          <a:xfrm>
+            <a:off x="4387850" y="3966766"/>
+            <a:ext cx="1240334" cy="1030982"/>
           </a:xfrm>
           <a:prstGeom prst="roundRect">
             <a:avLst>
-              <a:gd name="adj" fmla="val 50000"/>
+              <a:gd name="adj" fmla="val 10471"/>
             </a:avLst>
           </a:prstGeom>
           <a:solidFill>
-            <a:srgbClr val="E5F6EC"/>
+            <a:srgbClr val="FFFFFF"/>
+          </a:solidFill>
+          <a:ln w="12700">
+            <a:solidFill>
+              <a:srgbClr val="D8E0EB"/>
+            </a:solidFill>
+            <a:prstDash val="solid"/>
+          </a:ln>
+        </p:spPr>
+      </p:sp>
+      <p:sp>
+        <p:nvSpPr>
+          <p:cNvPr id="29" name="p1-av"/>
+          <p:cNvSpPr/>
+          <p:nvPr/>
+        </p:nvSpPr>
+        <p:spPr>
+          <a:xfrm>
+            <a:off x="4727873" y="4116586"/>
+            <a:ext cx="88900" cy="88900"/>
+          </a:xfrm>
+          <a:prstGeom prst="ellipse">
+            <a:avLst/>
+          </a:prstGeom>
+          <a:solidFill>
+            <a:srgbClr val="00A94F"/>
+          </a:solidFill>
+          <a:ln/>
+        </p:spPr>
+      </p:sp>
+      <p:sp>
+        <p:nvSpPr>
+          <p:cNvPr id="30" name="p1-mem"/>
+          <p:cNvSpPr/>
+          <p:nvPr/>
+        </p:nvSpPr>
+        <p:spPr>
+          <a:xfrm>
+            <a:off x="5729784" y="3966766"/>
+            <a:ext cx="1240334" cy="1030982"/>
+          </a:xfrm>
+          <a:prstGeom prst="roundRect">
+            <a:avLst>
+              <a:gd name="adj" fmla="val 10471"/>
+            </a:avLst>
+          </a:prstGeom>
+          <a:solidFill>
+            <a:srgbClr val="FFFFFF"/>
+          </a:solidFill>
+          <a:ln w="12700">
+            <a:solidFill>
+              <a:srgbClr val="D8E0EB"/>
+            </a:solidFill>
+            <a:prstDash val="solid"/>
+          </a:ln>
+        </p:spPr>
+      </p:sp>
+      <p:sp>
+        <p:nvSpPr>
+          <p:cNvPr id="31" name="p1-av"/>
+          <p:cNvSpPr/>
+          <p:nvPr/>
+        </p:nvSpPr>
+        <p:spPr>
+          <a:xfrm>
+            <a:off x="6069905" y="4116586"/>
+            <a:ext cx="88900" cy="88900"/>
+          </a:xfrm>
+          <a:prstGeom prst="ellipse">
+            <a:avLst/>
+          </a:prstGeom>
+          <a:solidFill>
+            <a:srgbClr val="00A94F"/>
+          </a:solidFill>
+          <a:ln/>
+        </p:spPr>
+      </p:sp>
+      <p:sp>
+        <p:nvSpPr>
+          <p:cNvPr id="32" name="p1-mem"/>
+          <p:cNvSpPr/>
+          <p:nvPr/>
+        </p:nvSpPr>
+        <p:spPr>
+          <a:xfrm>
+            <a:off x="7071717" y="3966766"/>
+            <a:ext cx="1240334" cy="1030982"/>
+          </a:xfrm>
+          <a:prstGeom prst="roundRect">
+            <a:avLst>
+              <a:gd name="adj" fmla="val 10471"/>
+            </a:avLst>
+          </a:prstGeom>
+          <a:solidFill>
+            <a:srgbClr val="FFFFFF"/>
+          </a:solidFill>
+          <a:ln w="12700">
+            <a:solidFill>
+              <a:srgbClr val="D8E0EB"/>
+            </a:solidFill>
+            <a:prstDash val="solid"/>
+          </a:ln>
+        </p:spPr>
+      </p:sp>
+      <p:sp>
+        <p:nvSpPr>
+          <p:cNvPr id="33" name="p1-av"/>
+          <p:cNvSpPr/>
+          <p:nvPr/>
+        </p:nvSpPr>
+        <p:spPr>
+          <a:xfrm>
+            <a:off x="7414419" y="4116586"/>
+            <a:ext cx="88900" cy="88900"/>
+          </a:xfrm>
+          <a:prstGeom prst="ellipse">
+            <a:avLst/>
+          </a:prstGeom>
+          <a:solidFill>
+            <a:srgbClr val="00A94F"/>
           </a:solidFill>
           <a:ln/>
         </p:spPr>
       </p:sp>
       <p:pic>
         <p:nvPicPr>
-          <p:cNvPr id="31" name="svg" descr="svg">    </p:cNvPr>
+          <p:cNvPr id="34" name="svg" descr="svg">    </p:cNvPr>
           <p:cNvPicPr>
             <a:picLocks noChangeAspect="1"/>
           </p:cNvPicPr>
@@ -1725,8 +1790,8 @@
         </p:blipFill>
         <p:spPr>
           <a:xfrm>
-            <a:off x="5325170" y="5330097"/>
-            <a:ext cx="118533" cy="135467"/>
+            <a:off x="4997450" y="5004098"/>
+            <a:ext cx="2705100" cy="226483"/>
           </a:xfrm>
           <a:prstGeom prst="rect">
             <a:avLst/>
@@ -1735,29 +1800,29 @@
       </p:pic>
       <p:sp>
         <p:nvSpPr>
-          <p:cNvPr id="32" name="p1-blk p1-b3"/>
-          <p:cNvSpPr/>
-          <p:nvPr/>
-        </p:nvSpPr>
-        <p:spPr>
-          <a:xfrm>
-            <a:off x="8661400" y="2436614"/>
-            <a:ext cx="2921000" cy="3263900"/>
+          <p:cNvPr id="35" name="p1-share"/>
+          <p:cNvSpPr/>
+          <p:nvPr/>
+        </p:nvSpPr>
+        <p:spPr>
+          <a:xfrm>
+            <a:off x="4381500" y="5230614"/>
+            <a:ext cx="3937000" cy="330200"/>
           </a:xfrm>
           <a:prstGeom prst="roundRect">
             <a:avLst>
-              <a:gd name="adj" fmla="val 4783"/>
+              <a:gd name="adj" fmla="val 50000"/>
             </a:avLst>
           </a:prstGeom>
           <a:solidFill>
-            <a:srgbClr val="EEF4FC"/>
+            <a:srgbClr val="E5F6EC"/>
           </a:solidFill>
           <a:ln/>
         </p:spPr>
       </p:sp>
       <p:pic>
         <p:nvPicPr>
-          <p:cNvPr id="33" name="svg" descr="svg">    </p:cNvPr>
+          <p:cNvPr id="36" name="svg" descr="svg">    </p:cNvPr>
           <p:cNvPicPr>
             <a:picLocks noChangeAspect="1"/>
           </p:cNvPicPr>
@@ -1771,6 +1836,52 @@
         </p:blipFill>
         <p:spPr>
           <a:xfrm>
+            <a:off x="5325170" y="5330097"/>
+            <a:ext cx="118533" cy="135467"/>
+          </a:xfrm>
+          <a:prstGeom prst="rect">
+            <a:avLst/>
+          </a:prstGeom>
+        </p:spPr>
+      </p:pic>
+      <p:sp>
+        <p:nvSpPr>
+          <p:cNvPr id="37" name="p1-blk p1-b3"/>
+          <p:cNvSpPr/>
+          <p:nvPr/>
+        </p:nvSpPr>
+        <p:spPr>
+          <a:xfrm>
+            <a:off x="8661400" y="2436614"/>
+            <a:ext cx="2921000" cy="3263900"/>
+          </a:xfrm>
+          <a:prstGeom prst="roundRect">
+            <a:avLst>
+              <a:gd name="adj" fmla="val 4783"/>
+            </a:avLst>
+          </a:prstGeom>
+          <a:solidFill>
+            <a:srgbClr val="EEF4FC"/>
+          </a:solidFill>
+          <a:ln/>
+        </p:spPr>
+      </p:sp>
+      <p:pic>
+        <p:nvPicPr>
+          <p:cNvPr id="38" name="svg" descr="svg">    </p:cNvPr>
+          <p:cNvPicPr>
+            <a:picLocks noChangeAspect="1"/>
+          </p:cNvPicPr>
+          <p:nvPr/>
+        </p:nvPicPr>
+        <p:blipFill>
+          <a:blip r:embed="rId9"/>
+          <a:stretch>
+            <a:fillRect/>
+          </a:stretch>
+        </p:blipFill>
+        <p:spPr>
+          <a:xfrm>
             <a:off x="9359900" y="2591131"/>
             <a:ext cx="1524000" cy="2717800"/>
           </a:xfrm>
@@ -1781,7 +1892,7 @@
       </p:pic>
       <p:sp>
         <p:nvSpPr>
-          <p:cNvPr id="34" name="key"/>
+          <p:cNvPr id="39" name="key"/>
           <p:cNvSpPr/>
           <p:nvPr/>
         </p:nvSpPr>
@@ -1803,7 +1914,7 @@
       </p:sp>
       <p:sp>
         <p:nvSpPr>
-          <p:cNvPr id="35" name="i"/>
+          <p:cNvPr id="40" name="i"/>
           <p:cNvSpPr/>
           <p:nvPr/>
         </p:nvSpPr>
@@ -1823,7 +1934,7 @@
       </p:sp>
       <p:sp>
         <p:nvSpPr>
-          <p:cNvPr id="36" name="b"/>
+          <p:cNvPr id="41" name="b"/>
           <p:cNvSpPr/>
           <p:nvPr/>
         </p:nvSpPr>
@@ -1843,7 +1954,7 @@
       </p:sp>
       <p:sp>
         <p:nvSpPr>
-          <p:cNvPr id="37" name="i"/>
+          <p:cNvPr id="42" name="i"/>
           <p:cNvSpPr/>
           <p:nvPr/>
         </p:nvSpPr>
@@ -1863,7 +1974,7 @@
       </p:sp>
       <p:sp>
         <p:nvSpPr>
-          <p:cNvPr id="38" name="b"/>
+          <p:cNvPr id="43" name="b"/>
           <p:cNvSpPr/>
           <p:nvPr/>
         </p:nvSpPr>
@@ -1883,7 +1994,7 @@
       </p:sp>
       <p:sp>
         <p:nvSpPr>
-          <p:cNvPr id="39" name="i"/>
+          <p:cNvPr id="44" name="i"/>
           <p:cNvSpPr/>
           <p:nvPr/>
         </p:nvSpPr>
@@ -1903,7 +2014,7 @@
       </p:sp>
       <p:sp>
         <p:nvSpPr>
-          <p:cNvPr id="40" name="01"/>
+          <p:cNvPr id="45" name="01"/>
           <p:cNvSpPr txBox="1"/>
           <p:nvPr/>
         </p:nvSpPr>
@@ -1942,7 +2053,7 @@
       </p:sp>
       <p:sp>
         <p:nvSpPr>
-          <p:cNvPr id="41" name="PT 주제 1 · 가장 중요하게 생각하는 가치와 실천 경험"/>
+          <p:cNvPr id="46" name="PT 주제 1 · 가장 중요하게 생각하는 가치와 실천 경험"/>
           <p:cNvSpPr txBox="1"/>
           <p:nvPr/>
         </p:nvSpPr>
@@ -1981,7 +2092,7 @@
       </p:sp>
       <p:sp>
         <p:nvSpPr>
-          <p:cNvPr id="42" name="제가 가장 중요하게 생각하는 가치는"/>
+          <p:cNvPr id="47" name="제가 가장 중요하게 생각하는 가치는"/>
           <p:cNvSpPr txBox="1"/>
           <p:nvPr/>
         </p:nvSpPr>
@@ -2020,7 +2131,7 @@
       </p:sp>
       <p:sp>
         <p:nvSpPr>
-          <p:cNvPr id="43" name="공동의 목표를 공유하며 함께 성과를 만드는 협업입니다"/>
+          <p:cNvPr id="48" name="공동의 목표를 공유하며 함께 성과를 만드는 협업입니다"/>
           <p:cNvSpPr txBox="1"/>
           <p:nvPr/>
         </p:nvSpPr>
@@ -2101,7 +2212,7 @@
       </p:sp>
       <p:sp>
         <p:nvSpPr>
-          <p:cNvPr id="44" name="학생 BIM 경진대회 · 4인 팀 팀장"/>
+          <p:cNvPr id="49" name="학생 BIM 경진대회 · 4인 팀 팀장"/>
           <p:cNvSpPr txBox="1"/>
           <p:nvPr/>
         </p:nvSpPr>
@@ -2140,7 +2251,7 @@
       </p:sp>
       <p:sp>
         <p:nvSpPr>
-          <p:cNvPr id="45" name="01"/>
+          <p:cNvPr id="50" name="01"/>
           <p:cNvSpPr txBox="1"/>
           <p:nvPr/>
         </p:nvSpPr>
@@ -2179,14 +2290,14 @@
       </p:sp>
       <p:sp>
         <p:nvSpPr>
-          <p:cNvPr id="46" name="의견을 모아 주제를 정하다"/>
+          <p:cNvPr id="51" name="충돌을 조율해 주제를 정하다"/>
           <p:cNvSpPr txBox="1"/>
           <p:nvPr/>
         </p:nvSpPr>
         <p:spPr>
           <a:xfrm>
             <a:off x="1111052" y="2086124"/>
-            <a:ext cx="2136777" cy="234950"/>
+            <a:ext cx="2319776" cy="234950"/>
           </a:xfrm>
           <a:prstGeom prst="rect">
             <a:avLst/>
@@ -2210,7 +2321,7 @@
                 <a:ea typeface="Paperlogy 8 ExtraBold" pitchFamily="34" charset="-127"/>
                 <a:cs typeface="Paperlogy 8 ExtraBold" pitchFamily="34" charset="-120"/>
               </a:rPr>
-              <a:t>의견을 모아 주제를 정하다</a:t>
+              <a:t>충돌을 조율해 주제를 정하다</a:t>
             </a:r>
             <a:endParaRPr lang="en-US" sz="1600" dirty="0"/>
           </a:p>
@@ -2218,7 +2329,7 @@
       </p:sp>
       <p:sp>
         <p:nvSpPr>
-          <p:cNvPr id="47" name="02"/>
+          <p:cNvPr id="52" name="02"/>
           <p:cNvSpPr txBox="1"/>
           <p:nvPr/>
         </p:nvSpPr>
@@ -2257,7 +2368,7 @@
       </p:sp>
       <p:sp>
         <p:nvSpPr>
-          <p:cNvPr id="48" name="강점에 맞게 역할을 나누다"/>
+          <p:cNvPr id="53" name="강점에 맞게 역할을 나누다"/>
           <p:cNvSpPr txBox="1"/>
           <p:nvPr/>
         </p:nvSpPr>
@@ -2296,7 +2407,7 @@
       </p:sp>
       <p:sp>
         <p:nvSpPr>
-          <p:cNvPr id="49" name="03"/>
+          <p:cNvPr id="54" name="03"/>
           <p:cNvSpPr txBox="1"/>
           <p:nvPr/>
         </p:nvSpPr>
@@ -2335,7 +2446,7 @@
       </p:sp>
       <p:sp>
         <p:nvSpPr>
-          <p:cNvPr id="50" name="3주 만에 완성, 장려상"/>
+          <p:cNvPr id="55" name="3주 만에 완성, 장려상"/>
           <p:cNvSpPr txBox="1"/>
           <p:nvPr/>
         </p:nvSpPr>
@@ -2374,13 +2485,13 @@
       </p:sp>
       <p:sp>
         <p:nvSpPr>
-          <p:cNvPr id="51" name="마감 3주 전까지 주제 미확정"/>
-          <p:cNvSpPr txBox="1"/>
-          <p:nvPr/>
-        </p:nvSpPr>
-        <p:spPr>
-          <a:xfrm>
-            <a:off x="1631504" y="2582664"/>
+          <p:cNvPr id="56" name="마감 3주 전까지 주제 미확정"/>
+          <p:cNvSpPr txBox="1"/>
+          <p:nvPr/>
+        </p:nvSpPr>
+        <p:spPr>
+          <a:xfrm>
+            <a:off x="1707704" y="2604889"/>
             <a:ext cx="1468305" cy="152400"/>
           </a:xfrm>
           <a:prstGeom prst="rect">
@@ -2399,13 +2510,339 @@
             <a:r>
               <a:rPr lang="ko-KR" altLang="en-US" sz="1000" spc="-20" kern="0" dirty="0">
                 <a:solidFill>
-                  <a:srgbClr val="8691A5"/>
+                  <a:srgbClr val="1C2536"/>
+                </a:solidFill>
+                <a:latin typeface="Paperlogy 7 Bold" pitchFamily="34" charset="0"/>
+                <a:ea typeface="Paperlogy 7 Bold" pitchFamily="34" charset="-127"/>
+                <a:cs typeface="Paperlogy 7 Bold" pitchFamily="34" charset="-120"/>
+              </a:rPr>
+              <a:t>마감 3주 전까지 주제 미확정</a:t>
+            </a:r>
+            <a:endParaRPr lang="en-US" sz="1000" dirty="0"/>
+          </a:p>
+        </p:txBody>
+      </p:sp>
+      <p:sp>
+        <p:nvSpPr>
+          <p:cNvPr id="57" name="참신성"/>
+          <p:cNvSpPr txBox="1"/>
+          <p:nvPr/>
+        </p:nvSpPr>
+        <p:spPr>
+          <a:xfrm>
+            <a:off x="1380827" y="2932906"/>
+            <a:ext cx="476845" cy="190500"/>
+          </a:xfrm>
+          <a:prstGeom prst="rect">
+            <a:avLst/>
+          </a:prstGeom>
+          <a:noFill/>
+          <a:ln/>
+        </p:spPr>
+        <p:txBody>
+          <a:bodyPr wrap="none" lIns="0" tIns="0" rIns="0" bIns="0" rtlCol="0" anchor="ctr"/>
+          <a:lstStyle/>
+          <a:p>
+            <a:pPr algn="l" indent="0" marL="0">
+              <a:buNone/>
+            </a:pPr>
+            <a:r>
+              <a:rPr lang="ko-KR" altLang="en-US" sz="1300" spc="-26" kern="0" dirty="0">
+                <a:solidFill>
+                  <a:srgbClr val="0B2147"/>
+                </a:solidFill>
+                <a:latin typeface="Paperlogy 7 Bold" pitchFamily="34" charset="0"/>
+                <a:ea typeface="Paperlogy 7 Bold" pitchFamily="34" charset="-127"/>
+                <a:cs typeface="Paperlogy 7 Bold" pitchFamily="34" charset="-120"/>
+              </a:rPr>
+              <a:t>참신성</a:t>
+            </a:r>
+            <a:endParaRPr lang="en-US" sz="1300" dirty="0"/>
+          </a:p>
+        </p:txBody>
+      </p:sp>
+      <p:sp>
+        <p:nvSpPr>
+          <p:cNvPr id="58" name="구현 가능성"/>
+          <p:cNvSpPr txBox="1"/>
+          <p:nvPr/>
+        </p:nvSpPr>
+        <p:spPr>
+          <a:xfrm>
+            <a:off x="2822476" y="2932906"/>
+            <a:ext cx="793849" cy="190500"/>
+          </a:xfrm>
+          <a:prstGeom prst="rect">
+            <a:avLst/>
+          </a:prstGeom>
+          <a:noFill/>
+          <a:ln/>
+        </p:spPr>
+        <p:txBody>
+          <a:bodyPr wrap="none" lIns="0" tIns="0" rIns="0" bIns="0" rtlCol="0" anchor="ctr"/>
+          <a:lstStyle/>
+          <a:p>
+            <a:pPr algn="l" indent="0" marL="0">
+              <a:buNone/>
+            </a:pPr>
+            <a:r>
+              <a:rPr lang="ko-KR" altLang="en-US" sz="1300" spc="-26" kern="0" dirty="0">
+                <a:solidFill>
+                  <a:srgbClr val="0B2147"/>
+                </a:solidFill>
+                <a:latin typeface="Paperlogy 7 Bold" pitchFamily="34" charset="0"/>
+                <a:ea typeface="Paperlogy 7 Bold" pitchFamily="34" charset="-127"/>
+                <a:cs typeface="Paperlogy 7 Bold" pitchFamily="34" charset="-120"/>
+              </a:rPr>
+              <a:t>구현 가능성</a:t>
+            </a:r>
+            <a:endParaRPr lang="en-US" sz="1300" dirty="0"/>
+          </a:p>
+        </p:txBody>
+      </p:sp>
+      <p:sp>
+        <p:nvSpPr>
+          <p:cNvPr id="59" name="VS"/>
+          <p:cNvSpPr txBox="1"/>
+          <p:nvPr/>
+        </p:nvSpPr>
+        <p:spPr>
+          <a:xfrm>
+            <a:off x="2228751" y="2954139"/>
+            <a:ext cx="241498" cy="158750"/>
+          </a:xfrm>
+          <a:prstGeom prst="rect">
+            <a:avLst/>
+          </a:prstGeom>
+          <a:noFill/>
+          <a:ln/>
+        </p:spPr>
+        <p:txBody>
+          <a:bodyPr wrap="none" lIns="0" tIns="0" rIns="0" bIns="0" rtlCol="0" anchor="ctr"/>
+          <a:lstStyle/>
+          <a:p>
+            <a:pPr algn="l" indent="0" marL="0">
+              <a:buNone/>
+            </a:pPr>
+            <a:r>
+              <a:rPr lang="ko-KR" altLang="en-US" sz="1050" spc="21" kern="0" dirty="0">
+                <a:solidFill>
+                  <a:srgbClr val="FFFFFF"/>
+                </a:solidFill>
+                <a:latin typeface="Paperlogy 9 Black" pitchFamily="34" charset="0"/>
+                <a:ea typeface="Paperlogy 9 Black" pitchFamily="34" charset="-127"/>
+                <a:cs typeface="Paperlogy 9 Black" pitchFamily="34" charset="-120"/>
+              </a:rPr>
+              <a:t>VS</a:t>
+            </a:r>
+            <a:endParaRPr lang="en-US" sz="1050" dirty="0"/>
+          </a:p>
+        </p:txBody>
+      </p:sp>
+      <p:sp>
+        <p:nvSpPr>
+          <p:cNvPr id="60" name="경청 · 수상작 분석 · 교수님 조언"/>
+          <p:cNvSpPr txBox="1"/>
+          <p:nvPr/>
+        </p:nvSpPr>
+        <p:spPr>
+          <a:xfrm>
+            <a:off x="1402209" y="3306564"/>
+            <a:ext cx="1954409" cy="177800"/>
+          </a:xfrm>
+          <a:prstGeom prst="rect">
+            <a:avLst/>
+          </a:prstGeom>
+          <a:noFill/>
+          <a:ln/>
+        </p:spPr>
+        <p:txBody>
+          <a:bodyPr wrap="none" lIns="0" tIns="0" rIns="0" bIns="0" rtlCol="0" anchor="ctr"/>
+          <a:lstStyle/>
+          <a:p>
+            <a:pPr algn="l" indent="0" marL="0">
+              <a:buNone/>
+            </a:pPr>
+            <a:r>
+              <a:rPr lang="ko-KR" altLang="en-US" sz="1200" spc="-24" kern="0" dirty="0">
+                <a:solidFill>
+                  <a:srgbClr val="1C2536"/>
                 </a:solidFill>
                 <a:latin typeface="Paperlogy 6 SemiBold" pitchFamily="34" charset="0"/>
                 <a:ea typeface="Paperlogy 6 SemiBold" pitchFamily="34" charset="-127"/>
                 <a:cs typeface="Paperlogy 6 SemiBold" pitchFamily="34" charset="-120"/>
               </a:rPr>
-              <a:t>마감 3주 전까지 주제 미확정</a:t>
+              <a:t>경청 · 수상작 분석 · 교수님 조언</a:t>
+            </a:r>
+            <a:endParaRPr lang="en-US" sz="1200" dirty="0"/>
+          </a:p>
+        </p:txBody>
+      </p:sp>
+      <p:sp>
+        <p:nvSpPr>
+          <p:cNvPr id="61" name="판단 기준 마련"/>
+          <p:cNvSpPr txBox="1"/>
+          <p:nvPr/>
+        </p:nvSpPr>
+        <p:spPr>
+          <a:xfrm>
+            <a:off x="1900386" y="3888184"/>
+            <a:ext cx="898273" cy="177800"/>
+          </a:xfrm>
+          <a:prstGeom prst="rect">
+            <a:avLst/>
+          </a:prstGeom>
+          <a:noFill/>
+          <a:ln/>
+        </p:spPr>
+        <p:txBody>
+          <a:bodyPr wrap="none" lIns="0" tIns="0" rIns="0" bIns="0" rtlCol="0" anchor="ctr"/>
+          <a:lstStyle/>
+          <a:p>
+            <a:pPr algn="l" indent="0" marL="0">
+              <a:buNone/>
+            </a:pPr>
+            <a:r>
+              <a:rPr lang="ko-KR" altLang="en-US" sz="1200" spc="-24" kern="0" dirty="0">
+                <a:solidFill>
+                  <a:srgbClr val="004B8D"/>
+                </a:solidFill>
+                <a:latin typeface="Paperlogy 8 ExtraBold" pitchFamily="34" charset="0"/>
+                <a:ea typeface="Paperlogy 8 ExtraBold" pitchFamily="34" charset="-127"/>
+                <a:cs typeface="Paperlogy 8 ExtraBold" pitchFamily="34" charset="-120"/>
+              </a:rPr>
+              <a:t>판단 기준 마련</a:t>
+            </a:r>
+            <a:endParaRPr lang="en-US" sz="1200" dirty="0"/>
+          </a:p>
+        </p:txBody>
+      </p:sp>
+      <p:sp>
+        <p:nvSpPr>
+          <p:cNvPr id="62" name="‘유닛 모듈러 기반 사용자 맞춤형"/>
+          <p:cNvSpPr txBox="1"/>
+          <p:nvPr/>
+        </p:nvSpPr>
+        <p:spPr>
+          <a:xfrm>
+            <a:off x="914400" y="4506714"/>
+            <a:ext cx="2741936" cy="254000"/>
+          </a:xfrm>
+          <a:prstGeom prst="rect">
+            <a:avLst/>
+          </a:prstGeom>
+          <a:noFill/>
+          <a:ln/>
+        </p:spPr>
+        <p:txBody>
+          <a:bodyPr wrap="none" lIns="0" tIns="0" rIns="0" bIns="0" rtlCol="0" anchor="ctr"/>
+          <a:lstStyle/>
+          <a:p>
+            <a:pPr algn="l" indent="0" marL="0">
+              <a:buNone/>
+            </a:pPr>
+            <a:r>
+              <a:rPr lang="ko-KR" altLang="en-US" sz="1700" spc="-59" kern="0" dirty="0">
+                <a:solidFill>
+                  <a:srgbClr val="FFFFFF"/>
+                </a:solidFill>
+                <a:latin typeface="Paperlogy 8 ExtraBold" pitchFamily="34" charset="0"/>
+                <a:ea typeface="Paperlogy 8 ExtraBold" pitchFamily="34" charset="-127"/>
+                <a:cs typeface="Paperlogy 8 ExtraBold" pitchFamily="34" charset="-120"/>
+              </a:rPr>
+              <a:t>‘유닛 모듈러 기반 사용자 맞춤형</a:t>
+            </a:r>
+            <a:endParaRPr lang="en-US" sz="1700" dirty="0"/>
+          </a:p>
+        </p:txBody>
+      </p:sp>
+      <p:sp>
+        <p:nvSpPr>
+          <p:cNvPr id="63" name="리모델링 방법’ 선정"/>
+          <p:cNvSpPr txBox="1"/>
+          <p:nvPr/>
+        </p:nvSpPr>
+        <p:spPr>
+          <a:xfrm>
+            <a:off x="914400" y="4776589"/>
+            <a:ext cx="1690428" cy="254000"/>
+          </a:xfrm>
+          <a:prstGeom prst="rect">
+            <a:avLst/>
+          </a:prstGeom>
+          <a:noFill/>
+          <a:ln/>
+        </p:spPr>
+        <p:txBody>
+          <a:bodyPr wrap="none" lIns="0" tIns="0" rIns="0" bIns="0" rtlCol="0" anchor="ctr"/>
+          <a:lstStyle/>
+          <a:p>
+            <a:pPr algn="l" indent="0" marL="0">
+              <a:buNone/>
+            </a:pPr>
+            <a:r>
+              <a:rPr lang="ko-KR" altLang="en-US" sz="1700" spc="-59" kern="0" dirty="0">
+                <a:solidFill>
+                  <a:srgbClr val="FFFFFF"/>
+                </a:solidFill>
+                <a:latin typeface="Paperlogy 8 ExtraBold" pitchFamily="34" charset="0"/>
+                <a:ea typeface="Paperlogy 8 ExtraBold" pitchFamily="34" charset="-127"/>
+                <a:cs typeface="Paperlogy 8 ExtraBold" pitchFamily="34" charset="-120"/>
+              </a:rPr>
+              <a:t>리모델링 방법’ </a:t>
+            </a:r>
+            <a:pPr algn="l" indent="0" marL="0">
+              <a:buNone/>
+            </a:pPr>
+            <a:r>
+              <a:rPr lang="ko-KR" altLang="en-US" sz="1700" spc="-59" kern="0" dirty="0">
+                <a:solidFill>
+                  <a:srgbClr val="45B9EC"/>
+                </a:solidFill>
+                <a:latin typeface="Paperlogy 8 ExtraBold" pitchFamily="34" charset="0"/>
+                <a:ea typeface="Paperlogy 8 ExtraBold" pitchFamily="34" charset="-127"/>
+                <a:cs typeface="Paperlogy 8 ExtraBold" pitchFamily="34" charset="-120"/>
+              </a:rPr>
+              <a:t>선정</a:t>
+            </a:r>
+            <a:endParaRPr lang="en-US" sz="1700" dirty="0"/>
+          </a:p>
+        </p:txBody>
+      </p:sp>
+      <p:sp>
+        <p:nvSpPr>
+          <p:cNvPr id="64" name="리모델링 규모에 따라 유닛 모듈러를 배치하고,"/>
+          <p:cNvSpPr txBox="1"/>
+          <p:nvPr/>
+        </p:nvSpPr>
+        <p:spPr>
+          <a:xfrm>
+            <a:off x="914400" y="5103614"/>
+            <a:ext cx="2365526" cy="152400"/>
+          </a:xfrm>
+          <a:prstGeom prst="rect">
+            <a:avLst/>
+          </a:prstGeom>
+          <a:noFill/>
+          <a:ln/>
+        </p:spPr>
+        <p:txBody>
+          <a:bodyPr wrap="none" lIns="0" tIns="0" rIns="0" bIns="0" rtlCol="0" anchor="ctr"/>
+          <a:lstStyle/>
+          <a:p>
+            <a:pPr algn="l" indent="0" marL="0">
+              <a:buNone/>
+            </a:pPr>
+            <a:r>
+              <a:rPr lang="ko-KR" altLang="en-US" sz="1000" spc="-20" kern="0" dirty="0">
+                <a:solidFill>
+                  <a:srgbClr val="C9CED7"/>
+                </a:solidFill>
+                <a:latin typeface="Paperlogy 5 Medium" pitchFamily="34" charset="0"/>
+                <a:ea typeface="Paperlogy 5 Medium" pitchFamily="34" charset="-127"/>
+                <a:cs typeface="Paperlogy 5 Medium" pitchFamily="34" charset="-120"/>
+              </a:rPr>
+              <a:t>리모델링 규모에 따라 유닛 모듈러를 배치하고,</a:t>
             </a:r>
             <a:endParaRPr lang="en-US" sz="1000" dirty="0"/>
           </a:p>
@@ -2413,38 +2850,623 @@
       </p:sp>
       <p:sp>
         <p:nvSpPr>
-          <p:cNvPr id="52" name="참신성"/>
-          <p:cNvSpPr txBox="1"/>
-          <p:nvPr/>
-        </p:nvSpPr>
-        <p:spPr>
-          <a:xfrm>
-            <a:off x="1060698" y="2865834"/>
-            <a:ext cx="444004" cy="177800"/>
-          </a:xfrm>
-          <a:prstGeom prst="rect">
-            <a:avLst/>
-          </a:prstGeom>
-          <a:noFill/>
-          <a:ln/>
-        </p:spPr>
-        <p:txBody>
-          <a:bodyPr wrap="none" lIns="0" tIns="0" rIns="0" bIns="0" rtlCol="0" anchor="ctr"/>
-          <a:lstStyle/>
-          <a:p>
-            <a:pPr algn="l" indent="0" marL="0">
+          <p:cNvPr id="65" name="모듈 수 · 자재 물량을 자동 산출"/>
+          <p:cNvSpPr txBox="1"/>
+          <p:nvPr/>
+        </p:nvSpPr>
+        <p:spPr>
+          <a:xfrm>
+            <a:off x="914400" y="5281414"/>
+            <a:ext cx="1587990" cy="152400"/>
+          </a:xfrm>
+          <a:prstGeom prst="rect">
+            <a:avLst/>
+          </a:prstGeom>
+          <a:noFill/>
+          <a:ln/>
+        </p:spPr>
+        <p:txBody>
+          <a:bodyPr wrap="none" lIns="0" tIns="0" rIns="0" bIns="0" rtlCol="0" anchor="ctr"/>
+          <a:lstStyle/>
+          <a:p>
+            <a:pPr algn="l" indent="0" marL="0">
+              <a:buNone/>
+            </a:pPr>
+            <a:r>
+              <a:rPr lang="ko-KR" altLang="en-US" sz="1000" spc="-20" kern="0" dirty="0">
+                <a:solidFill>
+                  <a:srgbClr val="C9CED7"/>
+                </a:solidFill>
+                <a:latin typeface="Paperlogy 5 Medium" pitchFamily="34" charset="0"/>
+                <a:ea typeface="Paperlogy 5 Medium" pitchFamily="34" charset="-127"/>
+                <a:cs typeface="Paperlogy 5 Medium" pitchFamily="34" charset="-120"/>
+              </a:rPr>
+              <a:t>모듈 수 · 자재 물량을 자동 산출</a:t>
+            </a:r>
+            <a:endParaRPr lang="en-US" sz="1000" dirty="0"/>
+          </a:p>
+        </p:txBody>
+      </p:sp>
+      <p:sp>
+        <p:nvSpPr>
+          <p:cNvPr id="66" name="팀장 · 나"/>
+          <p:cNvSpPr txBox="1"/>
+          <p:nvPr/>
+        </p:nvSpPr>
+        <p:spPr>
+          <a:xfrm>
+            <a:off x="6149578" y="2696964"/>
+            <a:ext cx="553045" cy="177800"/>
+          </a:xfrm>
+          <a:prstGeom prst="rect">
+            <a:avLst/>
+          </a:prstGeom>
+          <a:noFill/>
+          <a:ln/>
+        </p:spPr>
+        <p:txBody>
+          <a:bodyPr wrap="none" lIns="0" tIns="0" rIns="0" bIns="0" rtlCol="0" anchor="ctr"/>
+          <a:lstStyle/>
+          <a:p>
+            <a:pPr algn="ctr" indent="0" marL="0">
               <a:buNone/>
             </a:pPr>
             <a:r>
               <a:rPr lang="ko-KR" altLang="en-US" sz="1200" spc="-24" kern="0" dirty="0">
                 <a:solidFill>
-                  <a:srgbClr val="1C2536"/>
+                  <a:srgbClr val="FFFFFF"/>
+                </a:solidFill>
+                <a:latin typeface="Paperlogy 8 ExtraBold" pitchFamily="34" charset="0"/>
+                <a:ea typeface="Paperlogy 8 ExtraBold" pitchFamily="34" charset="-127"/>
+                <a:cs typeface="Paperlogy 8 ExtraBold" pitchFamily="34" charset="-120"/>
+              </a:rPr>
+              <a:t>팀장 · 나</a:t>
+            </a:r>
+            <a:endParaRPr lang="en-US" sz="1200" dirty="0"/>
+          </a:p>
+        </p:txBody>
+      </p:sp>
+      <p:sp>
+        <p:nvSpPr>
+          <p:cNvPr id="67" name="프로젝트 총괄 ·"/>
+          <p:cNvSpPr txBox="1"/>
+          <p:nvPr/>
+        </p:nvSpPr>
+        <p:spPr>
+          <a:xfrm>
+            <a:off x="5882198" y="2926755"/>
+            <a:ext cx="935504" cy="177800"/>
+          </a:xfrm>
+          <a:prstGeom prst="rect">
+            <a:avLst/>
+          </a:prstGeom>
+          <a:noFill/>
+          <a:ln/>
+        </p:spPr>
+        <p:txBody>
+          <a:bodyPr wrap="none" lIns="0" tIns="0" rIns="0" bIns="0" rtlCol="0" anchor="ctr"/>
+          <a:lstStyle/>
+          <a:p>
+            <a:pPr algn="ctr" indent="0" marL="0">
+              <a:buNone/>
+            </a:pPr>
+            <a:r>
+              <a:rPr lang="ko-KR" altLang="en-US" sz="1200" spc="-30" kern="0" dirty="0">
+                <a:solidFill>
+                  <a:srgbClr val="DADEE3"/>
+                </a:solidFill>
+                <a:latin typeface="Paperlogy 5 Medium" pitchFamily="34" charset="0"/>
+                <a:ea typeface="Paperlogy 5 Medium" pitchFamily="34" charset="-127"/>
+                <a:cs typeface="Paperlogy 5 Medium" pitchFamily="34" charset="-120"/>
+              </a:rPr>
+              <a:t>프로젝트 총괄 ·</a:t>
+            </a:r>
+            <a:endParaRPr lang="en-US" sz="1200" dirty="0"/>
+          </a:p>
+        </p:txBody>
+      </p:sp>
+      <p:sp>
+        <p:nvSpPr>
+          <p:cNvPr id="68" name="Dynamo 기반 자동화 알고리즘 개발"/>
+          <p:cNvSpPr txBox="1"/>
+          <p:nvPr/>
+        </p:nvSpPr>
+        <p:spPr>
+          <a:xfrm>
+            <a:off x="5185750" y="3132435"/>
+            <a:ext cx="2328400" cy="177800"/>
+          </a:xfrm>
+          <a:prstGeom prst="rect">
+            <a:avLst/>
+          </a:prstGeom>
+          <a:noFill/>
+          <a:ln/>
+        </p:spPr>
+        <p:txBody>
+          <a:bodyPr wrap="none" lIns="0" tIns="0" rIns="0" bIns="0" rtlCol="0" anchor="ctr"/>
+          <a:lstStyle/>
+          <a:p>
+            <a:pPr algn="ctr" indent="0" marL="0">
+              <a:buNone/>
+            </a:pPr>
+            <a:r>
+              <a:rPr lang="ko-KR" altLang="en-US" sz="1200" spc="-30" kern="0" dirty="0">
+                <a:solidFill>
+                  <a:srgbClr val="DADEE3"/>
+                </a:solidFill>
+                <a:latin typeface="Paperlogy 5 Medium" pitchFamily="34" charset="0"/>
+                <a:ea typeface="Paperlogy 5 Medium" pitchFamily="34" charset="-127"/>
+                <a:cs typeface="Paperlogy 5 Medium" pitchFamily="34" charset="-120"/>
+              </a:rPr>
+              <a:t>Dynamo 기반 자동화 알고리즘 개발</a:t>
+            </a:r>
+            <a:endParaRPr lang="en-US" sz="1200" dirty="0"/>
+          </a:p>
+        </p:txBody>
+      </p:sp>
+      <p:sp>
+        <p:nvSpPr>
+          <p:cNvPr id="69" name="팀원 A"/>
+          <p:cNvSpPr txBox="1"/>
+          <p:nvPr/>
+        </p:nvSpPr>
+        <p:spPr>
+          <a:xfrm>
+            <a:off x="4854873" y="4068366"/>
+            <a:ext cx="458589" cy="177800"/>
+          </a:xfrm>
+          <a:prstGeom prst="rect">
+            <a:avLst/>
+          </a:prstGeom>
+          <a:noFill/>
+          <a:ln/>
+        </p:spPr>
+        <p:txBody>
+          <a:bodyPr wrap="none" lIns="0" tIns="0" rIns="0" bIns="0" rtlCol="0" anchor="ctr"/>
+          <a:lstStyle/>
+          <a:p>
+            <a:pPr algn="ctr" indent="0" marL="0">
+              <a:buNone/>
+            </a:pPr>
+            <a:r>
+              <a:rPr lang="ko-KR" altLang="en-US" sz="1200" spc="-24" kern="0" dirty="0">
+                <a:solidFill>
+                  <a:srgbClr val="0B2147"/>
+                </a:solidFill>
+                <a:latin typeface="Paperlogy 8 ExtraBold" pitchFamily="34" charset="0"/>
+                <a:ea typeface="Paperlogy 8 ExtraBold" pitchFamily="34" charset="-127"/>
+                <a:cs typeface="Paperlogy 8 ExtraBold" pitchFamily="34" charset="-120"/>
+              </a:rPr>
+              <a:t>팀원 A</a:t>
+            </a:r>
+            <a:endParaRPr lang="en-US" sz="1200" dirty="0"/>
+          </a:p>
+        </p:txBody>
+      </p:sp>
+      <p:sp>
+        <p:nvSpPr>
+          <p:cNvPr id="70" name="유닛 모듈러 설계 ·"/>
+          <p:cNvSpPr txBox="1"/>
+          <p:nvPr/>
+        </p:nvSpPr>
+        <p:spPr>
+          <a:xfrm>
+            <a:off x="4455394" y="4298156"/>
+            <a:ext cx="1105146" cy="177800"/>
+          </a:xfrm>
+          <a:prstGeom prst="rect">
+            <a:avLst/>
+          </a:prstGeom>
+          <a:noFill/>
+          <a:ln/>
+        </p:spPr>
+        <p:txBody>
+          <a:bodyPr wrap="none" lIns="0" tIns="0" rIns="0" bIns="0" rtlCol="0" anchor="ctr"/>
+          <a:lstStyle/>
+          <a:p>
+            <a:pPr algn="ctr" indent="0" marL="0">
+              <a:buNone/>
+            </a:pPr>
+            <a:r>
+              <a:rPr lang="ko-KR" altLang="en-US" sz="1200" spc="-30" kern="0" dirty="0">
+                <a:solidFill>
+                  <a:srgbClr val="4B5568"/>
+                </a:solidFill>
+                <a:latin typeface="Paperlogy 5 Medium" pitchFamily="34" charset="0"/>
+                <a:ea typeface="Paperlogy 5 Medium" pitchFamily="34" charset="-127"/>
+                <a:cs typeface="Paperlogy 5 Medium" pitchFamily="34" charset="-120"/>
+              </a:rPr>
+              <a:t>유닛 모듈러 설계 ·</a:t>
+            </a:r>
+            <a:endParaRPr lang="en-US" sz="1200" dirty="0"/>
+          </a:p>
+        </p:txBody>
+      </p:sp>
+      <p:sp>
+        <p:nvSpPr>
+          <p:cNvPr id="71" name="배치계획"/>
+          <p:cNvSpPr txBox="1"/>
+          <p:nvPr/>
+        </p:nvSpPr>
+        <p:spPr>
+          <a:xfrm>
+            <a:off x="4721920" y="4503837"/>
+            <a:ext cx="572095" cy="177800"/>
+          </a:xfrm>
+          <a:prstGeom prst="rect">
+            <a:avLst/>
+          </a:prstGeom>
+          <a:noFill/>
+          <a:ln/>
+        </p:spPr>
+        <p:txBody>
+          <a:bodyPr wrap="none" lIns="0" tIns="0" rIns="0" bIns="0" rtlCol="0" anchor="ctr"/>
+          <a:lstStyle/>
+          <a:p>
+            <a:pPr algn="ctr" indent="0" marL="0">
+              <a:buNone/>
+            </a:pPr>
+            <a:r>
+              <a:rPr lang="ko-KR" altLang="en-US" sz="1200" spc="-30" kern="0" dirty="0">
+                <a:solidFill>
+                  <a:srgbClr val="4B5568"/>
+                </a:solidFill>
+                <a:latin typeface="Paperlogy 5 Medium" pitchFamily="34" charset="0"/>
+                <a:ea typeface="Paperlogy 5 Medium" pitchFamily="34" charset="-127"/>
+                <a:cs typeface="Paperlogy 5 Medium" pitchFamily="34" charset="-120"/>
+              </a:rPr>
+              <a:t>배치계획</a:t>
+            </a:r>
+            <a:endParaRPr lang="en-US" sz="1200" dirty="0"/>
+          </a:p>
+        </p:txBody>
+      </p:sp>
+      <p:sp>
+        <p:nvSpPr>
+          <p:cNvPr id="72" name="팀원 B"/>
+          <p:cNvSpPr txBox="1"/>
+          <p:nvPr/>
+        </p:nvSpPr>
+        <p:spPr>
+          <a:xfrm>
+            <a:off x="6196905" y="4068366"/>
+            <a:ext cx="458391" cy="177800"/>
+          </a:xfrm>
+          <a:prstGeom prst="rect">
+            <a:avLst/>
+          </a:prstGeom>
+          <a:noFill/>
+          <a:ln/>
+        </p:spPr>
+        <p:txBody>
+          <a:bodyPr wrap="none" lIns="0" tIns="0" rIns="0" bIns="0" rtlCol="0" anchor="ctr"/>
+          <a:lstStyle/>
+          <a:p>
+            <a:pPr algn="ctr" indent="0" marL="0">
+              <a:buNone/>
+            </a:pPr>
+            <a:r>
+              <a:rPr lang="ko-KR" altLang="en-US" sz="1200" spc="-24" kern="0" dirty="0">
+                <a:solidFill>
+                  <a:srgbClr val="0B2147"/>
+                </a:solidFill>
+                <a:latin typeface="Paperlogy 8 ExtraBold" pitchFamily="34" charset="0"/>
+                <a:ea typeface="Paperlogy 8 ExtraBold" pitchFamily="34" charset="-127"/>
+                <a:cs typeface="Paperlogy 8 ExtraBold" pitchFamily="34" charset="-120"/>
+              </a:rPr>
+              <a:t>팀원 B</a:t>
+            </a:r>
+            <a:endParaRPr lang="en-US" sz="1200" dirty="0"/>
+          </a:p>
+        </p:txBody>
+      </p:sp>
+      <p:sp>
+        <p:nvSpPr>
+          <p:cNvPr id="73" name="Revit 기반"/>
+          <p:cNvSpPr txBox="1"/>
+          <p:nvPr/>
+        </p:nvSpPr>
+        <p:spPr>
+          <a:xfrm>
+            <a:off x="5992912" y="4298156"/>
+            <a:ext cx="713978" cy="177800"/>
+          </a:xfrm>
+          <a:prstGeom prst="rect">
+            <a:avLst/>
+          </a:prstGeom>
+          <a:noFill/>
+          <a:ln/>
+        </p:spPr>
+        <p:txBody>
+          <a:bodyPr wrap="none" lIns="0" tIns="0" rIns="0" bIns="0" rtlCol="0" anchor="ctr"/>
+          <a:lstStyle/>
+          <a:p>
+            <a:pPr algn="ctr" indent="0" marL="0">
+              <a:buNone/>
+            </a:pPr>
+            <a:r>
+              <a:rPr lang="ko-KR" altLang="en-US" sz="1200" spc="-30" kern="0" dirty="0">
+                <a:solidFill>
+                  <a:srgbClr val="4B5568"/>
+                </a:solidFill>
+                <a:latin typeface="Paperlogy 5 Medium" pitchFamily="34" charset="0"/>
+                <a:ea typeface="Paperlogy 5 Medium" pitchFamily="34" charset="-127"/>
+                <a:cs typeface="Paperlogy 5 Medium" pitchFamily="34" charset="-120"/>
+              </a:rPr>
+              <a:t>Revit 기반</a:t>
+            </a:r>
+            <a:endParaRPr lang="en-US" sz="1200" dirty="0"/>
+          </a:p>
+        </p:txBody>
+      </p:sp>
+      <p:sp>
+        <p:nvSpPr>
+          <p:cNvPr id="74" name="BIM 모델링 ·"/>
+          <p:cNvSpPr txBox="1"/>
+          <p:nvPr/>
+        </p:nvSpPr>
+        <p:spPr>
+          <a:xfrm>
+            <a:off x="5930404" y="4503837"/>
+            <a:ext cx="838994" cy="177800"/>
+          </a:xfrm>
+          <a:prstGeom prst="rect">
+            <a:avLst/>
+          </a:prstGeom>
+          <a:noFill/>
+          <a:ln/>
+        </p:spPr>
+        <p:txBody>
+          <a:bodyPr wrap="none" lIns="0" tIns="0" rIns="0" bIns="0" rtlCol="0" anchor="ctr"/>
+          <a:lstStyle/>
+          <a:p>
+            <a:pPr algn="ctr" indent="0" marL="0">
+              <a:buNone/>
+            </a:pPr>
+            <a:r>
+              <a:rPr lang="ko-KR" altLang="en-US" sz="1200" spc="-30" kern="0" dirty="0">
+                <a:solidFill>
+                  <a:srgbClr val="4B5568"/>
+                </a:solidFill>
+                <a:latin typeface="Paperlogy 5 Medium" pitchFamily="34" charset="0"/>
+                <a:ea typeface="Paperlogy 5 Medium" pitchFamily="34" charset="-127"/>
+                <a:cs typeface="Paperlogy 5 Medium" pitchFamily="34" charset="-120"/>
+              </a:rPr>
+              <a:t>BIM 모델링 ·</a:t>
+            </a:r>
+            <a:endParaRPr lang="en-US" sz="1200" dirty="0"/>
+          </a:p>
+        </p:txBody>
+      </p:sp>
+      <p:sp>
+        <p:nvSpPr>
+          <p:cNvPr id="75" name="데이터 구축"/>
+          <p:cNvSpPr txBox="1"/>
+          <p:nvPr/>
+        </p:nvSpPr>
+        <p:spPr>
+          <a:xfrm>
+            <a:off x="5983883" y="4709517"/>
+            <a:ext cx="732036" cy="177800"/>
+          </a:xfrm>
+          <a:prstGeom prst="rect">
+            <a:avLst/>
+          </a:prstGeom>
+          <a:noFill/>
+          <a:ln/>
+        </p:spPr>
+        <p:txBody>
+          <a:bodyPr wrap="none" lIns="0" tIns="0" rIns="0" bIns="0" rtlCol="0" anchor="ctr"/>
+          <a:lstStyle/>
+          <a:p>
+            <a:pPr algn="ctr" indent="0" marL="0">
+              <a:buNone/>
+            </a:pPr>
+            <a:r>
+              <a:rPr lang="ko-KR" altLang="en-US" sz="1200" spc="-30" kern="0" dirty="0">
+                <a:solidFill>
+                  <a:srgbClr val="4B5568"/>
+                </a:solidFill>
+                <a:latin typeface="Paperlogy 5 Medium" pitchFamily="34" charset="0"/>
+                <a:ea typeface="Paperlogy 5 Medium" pitchFamily="34" charset="-127"/>
+                <a:cs typeface="Paperlogy 5 Medium" pitchFamily="34" charset="-120"/>
+              </a:rPr>
+              <a:t>데이터 구축</a:t>
+            </a:r>
+            <a:endParaRPr lang="en-US" sz="1200" dirty="0"/>
+          </a:p>
+        </p:txBody>
+      </p:sp>
+      <p:sp>
+        <p:nvSpPr>
+          <p:cNvPr id="76" name="팀원 C"/>
+          <p:cNvSpPr txBox="1"/>
+          <p:nvPr/>
+        </p:nvSpPr>
+        <p:spPr>
+          <a:xfrm>
+            <a:off x="7541419" y="4068366"/>
+            <a:ext cx="453231" cy="177800"/>
+          </a:xfrm>
+          <a:prstGeom prst="rect">
+            <a:avLst/>
+          </a:prstGeom>
+          <a:noFill/>
+          <a:ln/>
+        </p:spPr>
+        <p:txBody>
+          <a:bodyPr wrap="none" lIns="0" tIns="0" rIns="0" bIns="0" rtlCol="0" anchor="ctr"/>
+          <a:lstStyle/>
+          <a:p>
+            <a:pPr algn="ctr" indent="0" marL="0">
+              <a:buNone/>
+            </a:pPr>
+            <a:r>
+              <a:rPr lang="ko-KR" altLang="en-US" sz="1200" spc="-24" kern="0" dirty="0">
+                <a:solidFill>
+                  <a:srgbClr val="0B2147"/>
+                </a:solidFill>
+                <a:latin typeface="Paperlogy 8 ExtraBold" pitchFamily="34" charset="0"/>
+                <a:ea typeface="Paperlogy 8 ExtraBold" pitchFamily="34" charset="-127"/>
+                <a:cs typeface="Paperlogy 8 ExtraBold" pitchFamily="34" charset="-120"/>
+              </a:rPr>
+              <a:t>팀원 C</a:t>
+            </a:r>
+            <a:endParaRPr lang="en-US" sz="1200" dirty="0"/>
+          </a:p>
+        </p:txBody>
+      </p:sp>
+      <p:sp>
+        <p:nvSpPr>
+          <p:cNvPr id="77" name="리모델링 적용"/>
+          <p:cNvSpPr txBox="1"/>
+          <p:nvPr/>
+        </p:nvSpPr>
+        <p:spPr>
+          <a:xfrm>
+            <a:off x="7260630" y="4298156"/>
+            <a:ext cx="862409" cy="177800"/>
+          </a:xfrm>
+          <a:prstGeom prst="rect">
+            <a:avLst/>
+          </a:prstGeom>
+          <a:noFill/>
+          <a:ln/>
+        </p:spPr>
+        <p:txBody>
+          <a:bodyPr wrap="none" lIns="0" tIns="0" rIns="0" bIns="0" rtlCol="0" anchor="ctr"/>
+          <a:lstStyle/>
+          <a:p>
+            <a:pPr algn="ctr" indent="0" marL="0">
+              <a:buNone/>
+            </a:pPr>
+            <a:r>
+              <a:rPr lang="ko-KR" altLang="en-US" sz="1200" spc="-30" kern="0" dirty="0">
+                <a:solidFill>
+                  <a:srgbClr val="4B5568"/>
+                </a:solidFill>
+                <a:latin typeface="Paperlogy 5 Medium" pitchFamily="34" charset="0"/>
+                <a:ea typeface="Paperlogy 5 Medium" pitchFamily="34" charset="-127"/>
+                <a:cs typeface="Paperlogy 5 Medium" pitchFamily="34" charset="-120"/>
+              </a:rPr>
+              <a:t>리모델링 적용</a:t>
+            </a:r>
+            <a:endParaRPr lang="en-US" sz="1200" dirty="0"/>
+          </a:p>
+        </p:txBody>
+      </p:sp>
+      <p:sp>
+        <p:nvSpPr>
+          <p:cNvPr id="78" name="시나리오 구성 ·"/>
+          <p:cNvSpPr txBox="1"/>
+          <p:nvPr/>
+        </p:nvSpPr>
+        <p:spPr>
+          <a:xfrm>
+            <a:off x="7224132" y="4503837"/>
+            <a:ext cx="935504" cy="177800"/>
+          </a:xfrm>
+          <a:prstGeom prst="rect">
+            <a:avLst/>
+          </a:prstGeom>
+          <a:noFill/>
+          <a:ln/>
+        </p:spPr>
+        <p:txBody>
+          <a:bodyPr wrap="none" lIns="0" tIns="0" rIns="0" bIns="0" rtlCol="0" anchor="ctr"/>
+          <a:lstStyle/>
+          <a:p>
+            <a:pPr algn="ctr" indent="0" marL="0">
+              <a:buNone/>
+            </a:pPr>
+            <a:r>
+              <a:rPr lang="ko-KR" altLang="en-US" sz="1200" spc="-30" kern="0" dirty="0">
+                <a:solidFill>
+                  <a:srgbClr val="4B5568"/>
+                </a:solidFill>
+                <a:latin typeface="Paperlogy 5 Medium" pitchFamily="34" charset="0"/>
+                <a:ea typeface="Paperlogy 5 Medium" pitchFamily="34" charset="-127"/>
+                <a:cs typeface="Paperlogy 5 Medium" pitchFamily="34" charset="-120"/>
+              </a:rPr>
+              <a:t>시나리오 구성 ·</a:t>
+            </a:r>
+            <a:endParaRPr lang="en-US" sz="1200" dirty="0"/>
+          </a:p>
+        </p:txBody>
+      </p:sp>
+      <p:sp>
+        <p:nvSpPr>
+          <p:cNvPr id="79" name="시연 영상 제작"/>
+          <p:cNvSpPr txBox="1"/>
+          <p:nvPr/>
+        </p:nvSpPr>
+        <p:spPr>
+          <a:xfrm>
+            <a:off x="7245846" y="4709517"/>
+            <a:ext cx="892076" cy="177800"/>
+          </a:xfrm>
+          <a:prstGeom prst="rect">
+            <a:avLst/>
+          </a:prstGeom>
+          <a:noFill/>
+          <a:ln/>
+        </p:spPr>
+        <p:txBody>
+          <a:bodyPr wrap="none" lIns="0" tIns="0" rIns="0" bIns="0" rtlCol="0" anchor="ctr"/>
+          <a:lstStyle/>
+          <a:p>
+            <a:pPr algn="ctr" indent="0" marL="0">
+              <a:buNone/>
+            </a:pPr>
+            <a:r>
+              <a:rPr lang="ko-KR" altLang="en-US" sz="1200" spc="-30" kern="0" dirty="0">
+                <a:solidFill>
+                  <a:srgbClr val="4B5568"/>
+                </a:solidFill>
+                <a:latin typeface="Paperlogy 5 Medium" pitchFamily="34" charset="0"/>
+                <a:ea typeface="Paperlogy 5 Medium" pitchFamily="34" charset="-127"/>
+                <a:cs typeface="Paperlogy 5 Medium" pitchFamily="34" charset="-120"/>
+              </a:rPr>
+              <a:t>시연 영상 제작</a:t>
+            </a:r>
+            <a:endParaRPr lang="en-US" sz="1200" dirty="0"/>
+          </a:p>
+        </p:txBody>
+      </p:sp>
+      <p:sp>
+        <p:nvSpPr>
+          <p:cNvPr id="80" name="이틀마다 진행상황 공유 · 피드백"/>
+          <p:cNvSpPr txBox="1"/>
+          <p:nvPr/>
+        </p:nvSpPr>
+        <p:spPr>
+          <a:xfrm>
+            <a:off x="5528370" y="5304234"/>
+            <a:ext cx="1984173" cy="177800"/>
+          </a:xfrm>
+          <a:prstGeom prst="rect">
+            <a:avLst/>
+          </a:prstGeom>
+          <a:noFill/>
+          <a:ln/>
+        </p:spPr>
+        <p:txBody>
+          <a:bodyPr wrap="none" lIns="0" tIns="0" rIns="0" bIns="0" rtlCol="0" anchor="ctr"/>
+          <a:lstStyle/>
+          <a:p>
+            <a:pPr algn="l" indent="0" marL="0">
+              <a:buNone/>
+            </a:pPr>
+            <a:r>
+              <a:rPr lang="ko-KR" altLang="en-US" sz="1200" spc="-24" kern="0" dirty="0">
+                <a:solidFill>
+                  <a:srgbClr val="0B2147"/>
                 </a:solidFill>
                 <a:latin typeface="Paperlogy 7 Bold" pitchFamily="34" charset="0"/>
                 <a:ea typeface="Paperlogy 7 Bold" pitchFamily="34" charset="-127"/>
                 <a:cs typeface="Paperlogy 7 Bold" pitchFamily="34" charset="-120"/>
               </a:rPr>
-              <a:t>참신성</a:t>
+              <a:t>이틀마다 진행상황 공유 · 피드백</a:t>
             </a:r>
             <a:endParaRPr lang="en-US" sz="1200" dirty="0"/>
           </a:p>
@@ -2452,155 +3474,222 @@
       </p:sp>
       <p:sp>
         <p:nvSpPr>
-          <p:cNvPr id="53" name="구현 가능성"/>
-          <p:cNvSpPr txBox="1"/>
-          <p:nvPr/>
-        </p:nvSpPr>
-        <p:spPr>
-          <a:xfrm>
-            <a:off x="3048000" y="2865834"/>
-            <a:ext cx="736600" cy="177800"/>
-          </a:xfrm>
-          <a:prstGeom prst="rect">
-            <a:avLst/>
-          </a:prstGeom>
-          <a:noFill/>
-          <a:ln/>
-        </p:spPr>
-        <p:txBody>
-          <a:bodyPr wrap="none" lIns="0" tIns="0" rIns="0" bIns="0" rtlCol="0" anchor="ctr"/>
-          <a:lstStyle/>
-          <a:p>
-            <a:pPr algn="l" indent="0" marL="0">
-              <a:buNone/>
-            </a:pPr>
-            <a:r>
-              <a:rPr lang="ko-KR" altLang="en-US" sz="1200" spc="-24" kern="0" dirty="0">
-                <a:solidFill>
-                  <a:srgbClr val="1C2536"/>
+          <p:cNvPr id="81" name="리모델링 앱 개발 아이디어 시연 영상"/>
+          <p:cNvSpPr txBox="1"/>
+          <p:nvPr/>
+        </p:nvSpPr>
+        <p:spPr>
+          <a:xfrm>
+            <a:off x="9239200" y="3497064"/>
+            <a:ext cx="1871323" cy="152400"/>
+          </a:xfrm>
+          <a:prstGeom prst="rect">
+            <a:avLst/>
+          </a:prstGeom>
+          <a:noFill/>
+          <a:ln/>
+        </p:spPr>
+        <p:txBody>
+          <a:bodyPr wrap="none" lIns="0" tIns="0" rIns="0" bIns="0" rtlCol="0" anchor="ctr"/>
+          <a:lstStyle/>
+          <a:p>
+            <a:pPr algn="l" indent="0" marL="0">
+              <a:buNone/>
+            </a:pPr>
+            <a:r>
+              <a:rPr lang="ko-KR" altLang="en-US" sz="1000" spc="-20" kern="0" dirty="0">
+                <a:solidFill>
+                  <a:srgbClr val="4B5568"/>
+                </a:solidFill>
+                <a:latin typeface="Paperlogy 6 SemiBold" pitchFamily="34" charset="0"/>
+                <a:ea typeface="Paperlogy 6 SemiBold" pitchFamily="34" charset="-127"/>
+                <a:cs typeface="Paperlogy 6 SemiBold" pitchFamily="34" charset="-120"/>
+              </a:rPr>
+              <a:t>리모델링 앱 개발 아이디어 시연 영상</a:t>
+            </a:r>
+            <a:endParaRPr lang="en-US" sz="1000" dirty="0"/>
+          </a:p>
+        </p:txBody>
+      </p:sp>
+      <p:sp>
+        <p:nvSpPr>
+          <p:cNvPr id="82" name="장려상"/>
+          <p:cNvSpPr txBox="1"/>
+          <p:nvPr/>
+        </p:nvSpPr>
+        <p:spPr>
+          <a:xfrm>
+            <a:off x="9749433" y="4500364"/>
+            <a:ext cx="795734" cy="342900"/>
+          </a:xfrm>
+          <a:prstGeom prst="rect">
+            <a:avLst/>
+          </a:prstGeom>
+          <a:noFill/>
+          <a:ln/>
+        </p:spPr>
+        <p:txBody>
+          <a:bodyPr wrap="none" lIns="0" tIns="0" rIns="0" bIns="0" rtlCol="0" anchor="ctr"/>
+          <a:lstStyle/>
+          <a:p>
+            <a:pPr algn="l" indent="0" marL="0">
+              <a:buNone/>
+            </a:pPr>
+            <a:r>
+              <a:rPr lang="ko-KR" altLang="en-US" sz="2300" spc="-69" kern="0" dirty="0">
+                <a:solidFill>
+                  <a:srgbClr val="0B2147"/>
+                </a:solidFill>
+                <a:latin typeface="Paperlogy 9 Black" pitchFamily="34" charset="0"/>
+                <a:ea typeface="Paperlogy 9 Black" pitchFamily="34" charset="-127"/>
+                <a:cs typeface="Paperlogy 9 Black" pitchFamily="34" charset="-120"/>
+              </a:rPr>
+              <a:t>장려상</a:t>
+            </a:r>
+            <a:endParaRPr lang="en-US" sz="2300" dirty="0"/>
+          </a:p>
+        </p:txBody>
+      </p:sp>
+      <p:sp>
+        <p:nvSpPr>
+          <p:cNvPr id="83" name="학생 BIM 경진대회 장려상 · 남은 3주 내 완성"/>
+          <p:cNvSpPr txBox="1"/>
+          <p:nvPr/>
+        </p:nvSpPr>
+        <p:spPr>
+          <a:xfrm>
+            <a:off x="9014619" y="5376664"/>
+            <a:ext cx="2347436" cy="152400"/>
+          </a:xfrm>
+          <a:prstGeom prst="rect">
+            <a:avLst/>
+          </a:prstGeom>
+          <a:noFill/>
+          <a:ln/>
+        </p:spPr>
+        <p:txBody>
+          <a:bodyPr wrap="none" lIns="0" tIns="0" rIns="0" bIns="0" rtlCol="0" anchor="ctr"/>
+          <a:lstStyle/>
+          <a:p>
+            <a:pPr algn="l" indent="0" marL="0">
+              <a:buNone/>
+            </a:pPr>
+            <a:r>
+              <a:rPr lang="ko-KR" altLang="en-US" sz="1000" spc="-20" kern="0" dirty="0">
+                <a:solidFill>
+                  <a:srgbClr val="0B2147"/>
                 </a:solidFill>
                 <a:latin typeface="Paperlogy 7 Bold" pitchFamily="34" charset="0"/>
                 <a:ea typeface="Paperlogy 7 Bold" pitchFamily="34" charset="-127"/>
                 <a:cs typeface="Paperlogy 7 Bold" pitchFamily="34" charset="-120"/>
               </a:rPr>
-              <a:t>구현 가능성</a:t>
-            </a:r>
-            <a:endParaRPr lang="en-US" sz="1200" dirty="0"/>
-          </a:p>
-        </p:txBody>
-      </p:sp>
-      <p:sp>
-        <p:nvSpPr>
-          <p:cNvPr id="54" name="경청 · 수상작 분석 · 교수님 조언"/>
-          <p:cNvSpPr txBox="1"/>
-          <p:nvPr/>
-        </p:nvSpPr>
-        <p:spPr>
-          <a:xfrm>
-            <a:off x="1402209" y="3293864"/>
-            <a:ext cx="1954409" cy="177800"/>
-          </a:xfrm>
-          <a:prstGeom prst="rect">
-            <a:avLst/>
-          </a:prstGeom>
-          <a:noFill/>
-          <a:ln/>
-        </p:spPr>
-        <p:txBody>
-          <a:bodyPr wrap="none" lIns="0" tIns="0" rIns="0" bIns="0" rtlCol="0" anchor="ctr"/>
-          <a:lstStyle/>
-          <a:p>
-            <a:pPr algn="l" indent="0" marL="0">
-              <a:buNone/>
-            </a:pPr>
-            <a:r>
-              <a:rPr lang="ko-KR" altLang="en-US" sz="1200" spc="-24" kern="0" dirty="0">
-                <a:solidFill>
-                  <a:srgbClr val="1C2536"/>
-                </a:solidFill>
-                <a:latin typeface="Paperlogy 6 SemiBold" pitchFamily="34" charset="0"/>
-                <a:ea typeface="Paperlogy 6 SemiBold" pitchFamily="34" charset="-127"/>
-                <a:cs typeface="Paperlogy 6 SemiBold" pitchFamily="34" charset="-120"/>
-              </a:rPr>
-              <a:t>경청 · 수상작 분석 · 교수님 조언</a:t>
-            </a:r>
-            <a:endParaRPr lang="en-US" sz="1200" dirty="0"/>
-          </a:p>
-        </p:txBody>
-      </p:sp>
-      <p:sp>
-        <p:nvSpPr>
-          <p:cNvPr id="55" name="판단 기준 마련"/>
-          <p:cNvSpPr txBox="1"/>
-          <p:nvPr/>
-        </p:nvSpPr>
-        <p:spPr>
-          <a:xfrm>
-            <a:off x="1900386" y="3926284"/>
-            <a:ext cx="898273" cy="177800"/>
-          </a:xfrm>
-          <a:prstGeom prst="rect">
-            <a:avLst/>
-          </a:prstGeom>
-          <a:noFill/>
-          <a:ln/>
-        </p:spPr>
-        <p:txBody>
-          <a:bodyPr wrap="none" lIns="0" tIns="0" rIns="0" bIns="0" rtlCol="0" anchor="ctr"/>
-          <a:lstStyle/>
-          <a:p>
-            <a:pPr algn="l" indent="0" marL="0">
-              <a:buNone/>
-            </a:pPr>
-            <a:r>
-              <a:rPr lang="ko-KR" altLang="en-US" sz="1200" spc="-24" kern="0" dirty="0">
-                <a:solidFill>
-                  <a:srgbClr val="004B8D"/>
-                </a:solidFill>
-                <a:latin typeface="Paperlogy 8 ExtraBold" pitchFamily="34" charset="0"/>
-                <a:ea typeface="Paperlogy 8 ExtraBold" pitchFamily="34" charset="-127"/>
-                <a:cs typeface="Paperlogy 8 ExtraBold" pitchFamily="34" charset="-120"/>
-              </a:rPr>
-              <a:t>판단 기준 마련</a:t>
-            </a:r>
-            <a:endParaRPr lang="en-US" sz="1200" dirty="0"/>
-          </a:p>
-        </p:txBody>
-      </p:sp>
-      <p:sp>
-        <p:nvSpPr>
-          <p:cNvPr id="56" name="‘유닛 모듈러 기반 사용자 맞춤형"/>
-          <p:cNvSpPr txBox="1"/>
-          <p:nvPr/>
-        </p:nvSpPr>
-        <p:spPr>
-          <a:xfrm>
-            <a:off x="914400" y="4506714"/>
-            <a:ext cx="2741936" cy="254000"/>
-          </a:xfrm>
-          <a:prstGeom prst="rect">
-            <a:avLst/>
-          </a:prstGeom>
-          <a:noFill/>
-          <a:ln/>
-        </p:spPr>
-        <p:txBody>
-          <a:bodyPr wrap="none" lIns="0" tIns="0" rIns="0" bIns="0" rtlCol="0" anchor="ctr"/>
-          <a:lstStyle/>
-          <a:p>
-            <a:pPr algn="l" indent="0" marL="0">
-              <a:buNone/>
-            </a:pPr>
-            <a:r>
-              <a:rPr lang="ko-KR" altLang="en-US" sz="1700" spc="-59" kern="0" dirty="0">
+              <a:t>학생 BIM 경진대회 장려상 · 남은 3주 내 완성</a:t>
+            </a:r>
+            <a:endParaRPr lang="en-US" sz="1000" dirty="0"/>
+          </a:p>
+        </p:txBody>
+      </p:sp>
+      <p:sp>
+        <p:nvSpPr>
+          <p:cNvPr id="84" name="KEY MESSAGE"/>
+          <p:cNvSpPr txBox="1"/>
+          <p:nvPr/>
+        </p:nvSpPr>
+        <p:spPr>
+          <a:xfrm>
+            <a:off x="1308100" y="6007298"/>
+            <a:ext cx="1171825" cy="146050"/>
+          </a:xfrm>
+          <a:prstGeom prst="rect">
+            <a:avLst/>
+          </a:prstGeom>
+          <a:noFill/>
+          <a:ln/>
+        </p:spPr>
+        <p:txBody>
+          <a:bodyPr wrap="none" lIns="0" tIns="0" rIns="0" bIns="0" rtlCol="0" anchor="ctr"/>
+          <a:lstStyle/>
+          <a:p>
+            <a:pPr algn="l" indent="0" marL="0">
+              <a:buNone/>
+            </a:pPr>
+            <a:r>
+              <a:rPr lang="ko-KR" altLang="en-US" sz="950" spc="152" kern="0" dirty="0">
+                <a:solidFill>
+                  <a:srgbClr val="8FD3F5"/>
+                </a:solidFill>
+                <a:latin typeface="Paperlogy 7 Bold" pitchFamily="34" charset="0"/>
+                <a:ea typeface="Paperlogy 7 Bold" pitchFamily="34" charset="-127"/>
+                <a:cs typeface="Paperlogy 7 Bold" pitchFamily="34" charset="-120"/>
+              </a:rPr>
+              <a:t>KEY MESSAGE</a:t>
+            </a:r>
+            <a:endParaRPr lang="en-US" sz="950" dirty="0"/>
+          </a:p>
+        </p:txBody>
+      </p:sp>
+      <p:sp>
+        <p:nvSpPr>
+          <p:cNvPr id="85" name="서로 다른 사람을 하나의 공동 목표로 연결합니다"/>
+          <p:cNvSpPr txBox="1"/>
+          <p:nvPr/>
+        </p:nvSpPr>
+        <p:spPr>
+          <a:xfrm>
+            <a:off x="2591395" y="5954514"/>
+            <a:ext cx="4151660" cy="254000"/>
+          </a:xfrm>
+          <a:prstGeom prst="rect">
+            <a:avLst/>
+          </a:prstGeom>
+          <a:noFill/>
+          <a:ln/>
+        </p:spPr>
+        <p:txBody>
+          <a:bodyPr wrap="none" lIns="0" tIns="0" rIns="0" bIns="0" rtlCol="0" anchor="ctr"/>
+          <a:lstStyle/>
+          <a:p>
+            <a:pPr algn="l" indent="0" marL="0">
+              <a:buNone/>
+            </a:pPr>
+            <a:r>
+              <a:rPr lang="ko-KR" altLang="en-US" sz="1700" spc="-51" kern="0" dirty="0">
                 <a:solidFill>
                   <a:srgbClr val="FFFFFF"/>
                 </a:solidFill>
-                <a:latin typeface="Paperlogy 8 ExtraBold" pitchFamily="34" charset="0"/>
-                <a:ea typeface="Paperlogy 8 ExtraBold" pitchFamily="34" charset="-127"/>
-                <a:cs typeface="Paperlogy 8 ExtraBold" pitchFamily="34" charset="-120"/>
-              </a:rPr>
-              <a:t>‘유닛 모듈러 기반 사용자 맞춤형</a:t>
+                <a:latin typeface="Paperlogy 7 Bold" pitchFamily="34" charset="0"/>
+                <a:ea typeface="Paperlogy 7 Bold" pitchFamily="34" charset="-127"/>
+                <a:cs typeface="Paperlogy 7 Bold" pitchFamily="34" charset="-120"/>
+              </a:rPr>
+              <a:t>서로 다른 사람을 </a:t>
+            </a:r>
+            <a:pPr algn="l" indent="0" marL="0">
+              <a:buNone/>
+            </a:pPr>
+            <a:r>
+              <a:rPr lang="ko-KR" altLang="en-US" sz="1700" spc="-51" kern="0" dirty="0">
+                <a:solidFill>
+                  <a:srgbClr val="FDBB30"/>
+                </a:solidFill>
+                <a:latin typeface="Paperlogy 7 Bold" pitchFamily="34" charset="0"/>
+                <a:ea typeface="Paperlogy 7 Bold" pitchFamily="34" charset="-127"/>
+                <a:cs typeface="Paperlogy 7 Bold" pitchFamily="34" charset="-120"/>
+              </a:rPr>
+              <a:t>하나의 공동 목표</a:t>
+            </a:r>
+            <a:pPr algn="l" indent="0" marL="0">
+              <a:buNone/>
+            </a:pPr>
+            <a:r>
+              <a:rPr lang="ko-KR" altLang="en-US" sz="1700" spc="-51" kern="0" dirty="0">
+                <a:solidFill>
+                  <a:srgbClr val="FFFFFF"/>
+                </a:solidFill>
+                <a:latin typeface="Paperlogy 7 Bold" pitchFamily="34" charset="0"/>
+                <a:ea typeface="Paperlogy 7 Bold" pitchFamily="34" charset="-127"/>
+                <a:cs typeface="Paperlogy 7 Bold" pitchFamily="34" charset="-120"/>
+              </a:rPr>
+              <a:t>로 연결합니다</a:t>
             </a:r>
             <a:endParaRPr lang="en-US" sz="1700" dirty="0"/>
           </a:p>
@@ -2608,976 +3697,37 @@
       </p:sp>
       <p:sp>
         <p:nvSpPr>
-          <p:cNvPr id="57" name="리모델링 방법’ 선정"/>
-          <p:cNvSpPr txBox="1"/>
-          <p:nvPr/>
-        </p:nvSpPr>
-        <p:spPr>
-          <a:xfrm>
-            <a:off x="914400" y="4776589"/>
-            <a:ext cx="1690428" cy="254000"/>
-          </a:xfrm>
-          <a:prstGeom prst="rect">
-            <a:avLst/>
-          </a:prstGeom>
-          <a:noFill/>
-          <a:ln/>
-        </p:spPr>
-        <p:txBody>
-          <a:bodyPr wrap="none" lIns="0" tIns="0" rIns="0" bIns="0" rtlCol="0" anchor="ctr"/>
-          <a:lstStyle/>
-          <a:p>
-            <a:pPr algn="l" indent="0" marL="0">
-              <a:buNone/>
-            </a:pPr>
-            <a:r>
-              <a:rPr lang="ko-KR" altLang="en-US" sz="1700" spc="-59" kern="0" dirty="0">
-                <a:solidFill>
-                  <a:srgbClr val="FFFFFF"/>
-                </a:solidFill>
-                <a:latin typeface="Paperlogy 8 ExtraBold" pitchFamily="34" charset="0"/>
-                <a:ea typeface="Paperlogy 8 ExtraBold" pitchFamily="34" charset="-127"/>
-                <a:cs typeface="Paperlogy 8 ExtraBold" pitchFamily="34" charset="-120"/>
-              </a:rPr>
-              <a:t>리모델링 방법’ </a:t>
-            </a:r>
-            <a:pPr algn="l" indent="0" marL="0">
-              <a:buNone/>
-            </a:pPr>
-            <a:r>
-              <a:rPr lang="ko-KR" altLang="en-US" sz="1700" spc="-59" kern="0" dirty="0">
-                <a:solidFill>
-                  <a:srgbClr val="45B9EC"/>
-                </a:solidFill>
-                <a:latin typeface="Paperlogy 8 ExtraBold" pitchFamily="34" charset="0"/>
-                <a:ea typeface="Paperlogy 8 ExtraBold" pitchFamily="34" charset="-127"/>
-                <a:cs typeface="Paperlogy 8 ExtraBold" pitchFamily="34" charset="-120"/>
-              </a:rPr>
-              <a:t>선정</a:t>
-            </a:r>
-            <a:endParaRPr lang="en-US" sz="1700" dirty="0"/>
-          </a:p>
-        </p:txBody>
-      </p:sp>
-      <p:sp>
-        <p:nvSpPr>
-          <p:cNvPr id="58" name="리모델링 규모에 따라 유닛 모듈러를 배치하고,"/>
-          <p:cNvSpPr txBox="1"/>
-          <p:nvPr/>
-        </p:nvSpPr>
-        <p:spPr>
-          <a:xfrm>
-            <a:off x="914400" y="5103614"/>
-            <a:ext cx="2365526" cy="152400"/>
-          </a:xfrm>
-          <a:prstGeom prst="rect">
-            <a:avLst/>
-          </a:prstGeom>
-          <a:noFill/>
-          <a:ln/>
-        </p:spPr>
-        <p:txBody>
-          <a:bodyPr wrap="none" lIns="0" tIns="0" rIns="0" bIns="0" rtlCol="0" anchor="ctr"/>
-          <a:lstStyle/>
-          <a:p>
-            <a:pPr algn="l" indent="0" marL="0">
-              <a:buNone/>
-            </a:pPr>
-            <a:r>
-              <a:rPr lang="ko-KR" altLang="en-US" sz="1000" spc="-20" kern="0" dirty="0">
-                <a:solidFill>
-                  <a:srgbClr val="C9CED7"/>
+          <p:cNvPr id="86" name="2026년 하반기 신입사원 공개채용"/>
+          <p:cNvSpPr txBox="1"/>
+          <p:nvPr/>
+        </p:nvSpPr>
+        <p:spPr>
+          <a:xfrm>
+            <a:off x="609600" y="6425605"/>
+            <a:ext cx="1659507" cy="139700"/>
+          </a:xfrm>
+          <a:prstGeom prst="rect">
+            <a:avLst/>
+          </a:prstGeom>
+          <a:noFill/>
+          <a:ln/>
+        </p:spPr>
+        <p:txBody>
+          <a:bodyPr wrap="none" lIns="0" tIns="0" rIns="0" bIns="0" rtlCol="0" anchor="ctr"/>
+          <a:lstStyle/>
+          <a:p>
+            <a:pPr algn="l" indent="0" marL="0">
+              <a:buNone/>
+            </a:pPr>
+            <a:r>
+              <a:rPr lang="ko-KR" altLang="en-US" sz="900" spc="-9" kern="0" dirty="0">
+                <a:solidFill>
+                  <a:srgbClr val="8691A5"/>
                 </a:solidFill>
                 <a:latin typeface="Paperlogy 5 Medium" pitchFamily="34" charset="0"/>
                 <a:ea typeface="Paperlogy 5 Medium" pitchFamily="34" charset="-127"/>
                 <a:cs typeface="Paperlogy 5 Medium" pitchFamily="34" charset="-120"/>
               </a:rPr>
-              <a:t>리모델링 규모에 따라 유닛 모듈러를 배치하고,</a:t>
-            </a:r>
-            <a:endParaRPr lang="en-US" sz="1000" dirty="0"/>
-          </a:p>
-        </p:txBody>
-      </p:sp>
-      <p:sp>
-        <p:nvSpPr>
-          <p:cNvPr id="59" name="모듈 수 · 자재 물량을 자동 산출"/>
-          <p:cNvSpPr txBox="1"/>
-          <p:nvPr/>
-        </p:nvSpPr>
-        <p:spPr>
-          <a:xfrm>
-            <a:off x="914400" y="5281414"/>
-            <a:ext cx="1587990" cy="152400"/>
-          </a:xfrm>
-          <a:prstGeom prst="rect">
-            <a:avLst/>
-          </a:prstGeom>
-          <a:noFill/>
-          <a:ln/>
-        </p:spPr>
-        <p:txBody>
-          <a:bodyPr wrap="none" lIns="0" tIns="0" rIns="0" bIns="0" rtlCol="0" anchor="ctr"/>
-          <a:lstStyle/>
-          <a:p>
-            <a:pPr algn="l" indent="0" marL="0">
-              <a:buNone/>
-            </a:pPr>
-            <a:r>
-              <a:rPr lang="ko-KR" altLang="en-US" sz="1000" spc="-20" kern="0" dirty="0">
-                <a:solidFill>
-                  <a:srgbClr val="C9CED7"/>
-                </a:solidFill>
-                <a:latin typeface="Paperlogy 5 Medium" pitchFamily="34" charset="0"/>
-                <a:ea typeface="Paperlogy 5 Medium" pitchFamily="34" charset="-127"/>
-                <a:cs typeface="Paperlogy 5 Medium" pitchFamily="34" charset="-120"/>
-              </a:rPr>
-              <a:t>모듈 수 · 자재 물량을 자동 산출</a:t>
-            </a:r>
-            <a:endParaRPr lang="en-US" sz="1000" dirty="0"/>
-          </a:p>
-        </p:txBody>
-      </p:sp>
-      <p:sp>
-        <p:nvSpPr>
-          <p:cNvPr id="60" name="팀장 · 나"/>
-          <p:cNvSpPr txBox="1"/>
-          <p:nvPr/>
-        </p:nvSpPr>
-        <p:spPr>
-          <a:xfrm>
-            <a:off x="6149578" y="2696964"/>
-            <a:ext cx="553045" cy="177800"/>
-          </a:xfrm>
-          <a:prstGeom prst="rect">
-            <a:avLst/>
-          </a:prstGeom>
-          <a:noFill/>
-          <a:ln/>
-        </p:spPr>
-        <p:txBody>
-          <a:bodyPr wrap="none" lIns="0" tIns="0" rIns="0" bIns="0" rtlCol="0" anchor="ctr"/>
-          <a:lstStyle/>
-          <a:p>
-            <a:pPr algn="ctr" indent="0" marL="0">
-              <a:buNone/>
-            </a:pPr>
-            <a:r>
-              <a:rPr lang="ko-KR" altLang="en-US" sz="1200" spc="-24" kern="0" dirty="0">
-                <a:solidFill>
-                  <a:srgbClr val="FFFFFF"/>
-                </a:solidFill>
-                <a:latin typeface="Paperlogy 8 ExtraBold" pitchFamily="34" charset="0"/>
-                <a:ea typeface="Paperlogy 8 ExtraBold" pitchFamily="34" charset="-127"/>
-                <a:cs typeface="Paperlogy 8 ExtraBold" pitchFamily="34" charset="-120"/>
-              </a:rPr>
-              <a:t>팀장 · 나</a:t>
-            </a:r>
-            <a:endParaRPr lang="en-US" sz="1200" dirty="0"/>
-          </a:p>
-        </p:txBody>
-      </p:sp>
-      <p:sp>
-        <p:nvSpPr>
-          <p:cNvPr id="61" name="프로젝트 총괄 ·"/>
-          <p:cNvSpPr txBox="1"/>
-          <p:nvPr/>
-        </p:nvSpPr>
-        <p:spPr>
-          <a:xfrm>
-            <a:off x="5882198" y="2926755"/>
-            <a:ext cx="935504" cy="177800"/>
-          </a:xfrm>
-          <a:prstGeom prst="rect">
-            <a:avLst/>
-          </a:prstGeom>
-          <a:noFill/>
-          <a:ln/>
-        </p:spPr>
-        <p:txBody>
-          <a:bodyPr wrap="none" lIns="0" tIns="0" rIns="0" bIns="0" rtlCol="0" anchor="ctr"/>
-          <a:lstStyle/>
-          <a:p>
-            <a:pPr algn="ctr" indent="0" marL="0">
-              <a:buNone/>
-            </a:pPr>
-            <a:r>
-              <a:rPr lang="ko-KR" altLang="en-US" sz="1200" spc="-30" kern="0" dirty="0">
-                <a:solidFill>
-                  <a:srgbClr val="DADEE3"/>
-                </a:solidFill>
-                <a:latin typeface="Paperlogy 5 Medium" pitchFamily="34" charset="0"/>
-                <a:ea typeface="Paperlogy 5 Medium" pitchFamily="34" charset="-127"/>
-                <a:cs typeface="Paperlogy 5 Medium" pitchFamily="34" charset="-120"/>
-              </a:rPr>
-              <a:t>프로젝트 총괄 ·</a:t>
-            </a:r>
-            <a:endParaRPr lang="en-US" sz="1200" dirty="0"/>
-          </a:p>
-        </p:txBody>
-      </p:sp>
-      <p:sp>
-        <p:nvSpPr>
-          <p:cNvPr id="62" name="Dynamo 기반 자동화 알고리즘 개발"/>
-          <p:cNvSpPr txBox="1"/>
-          <p:nvPr/>
-        </p:nvSpPr>
-        <p:spPr>
-          <a:xfrm>
-            <a:off x="5185750" y="3132435"/>
-            <a:ext cx="2328400" cy="177800"/>
-          </a:xfrm>
-          <a:prstGeom prst="rect">
-            <a:avLst/>
-          </a:prstGeom>
-          <a:noFill/>
-          <a:ln/>
-        </p:spPr>
-        <p:txBody>
-          <a:bodyPr wrap="none" lIns="0" tIns="0" rIns="0" bIns="0" rtlCol="0" anchor="ctr"/>
-          <a:lstStyle/>
-          <a:p>
-            <a:pPr algn="ctr" indent="0" marL="0">
-              <a:buNone/>
-            </a:pPr>
-            <a:r>
-              <a:rPr lang="ko-KR" altLang="en-US" sz="1200" spc="-30" kern="0" dirty="0">
-                <a:solidFill>
-                  <a:srgbClr val="DADEE3"/>
-                </a:solidFill>
-                <a:latin typeface="Paperlogy 5 Medium" pitchFamily="34" charset="0"/>
-                <a:ea typeface="Paperlogy 5 Medium" pitchFamily="34" charset="-127"/>
-                <a:cs typeface="Paperlogy 5 Medium" pitchFamily="34" charset="-120"/>
-              </a:rPr>
-              <a:t>Dynamo 기반 자동화 알고리즘 개발</a:t>
-            </a:r>
-            <a:endParaRPr lang="en-US" sz="1200" dirty="0"/>
-          </a:p>
-        </p:txBody>
-      </p:sp>
-      <p:sp>
-        <p:nvSpPr>
-          <p:cNvPr id="63" name="팀원 A"/>
-          <p:cNvSpPr txBox="1"/>
-          <p:nvPr/>
-        </p:nvSpPr>
-        <p:spPr>
-          <a:xfrm>
-            <a:off x="4854873" y="4068366"/>
-            <a:ext cx="458589" cy="177800"/>
-          </a:xfrm>
-          <a:prstGeom prst="rect">
-            <a:avLst/>
-          </a:prstGeom>
-          <a:noFill/>
-          <a:ln/>
-        </p:spPr>
-        <p:txBody>
-          <a:bodyPr wrap="none" lIns="0" tIns="0" rIns="0" bIns="0" rtlCol="0" anchor="ctr"/>
-          <a:lstStyle/>
-          <a:p>
-            <a:pPr algn="ctr" indent="0" marL="0">
-              <a:buNone/>
-            </a:pPr>
-            <a:r>
-              <a:rPr lang="ko-KR" altLang="en-US" sz="1200" spc="-24" kern="0" dirty="0">
-                <a:solidFill>
-                  <a:srgbClr val="0B2147"/>
-                </a:solidFill>
-                <a:latin typeface="Paperlogy 8 ExtraBold" pitchFamily="34" charset="0"/>
-                <a:ea typeface="Paperlogy 8 ExtraBold" pitchFamily="34" charset="-127"/>
-                <a:cs typeface="Paperlogy 8 ExtraBold" pitchFamily="34" charset="-120"/>
-              </a:rPr>
-              <a:t>팀원 A</a:t>
-            </a:r>
-            <a:endParaRPr lang="en-US" sz="1200" dirty="0"/>
-          </a:p>
-        </p:txBody>
-      </p:sp>
-      <p:sp>
-        <p:nvSpPr>
-          <p:cNvPr id="64" name="유닛 모듈러 설계 ·"/>
-          <p:cNvSpPr txBox="1"/>
-          <p:nvPr/>
-        </p:nvSpPr>
-        <p:spPr>
-          <a:xfrm>
-            <a:off x="4455394" y="4298156"/>
-            <a:ext cx="1105146" cy="177800"/>
-          </a:xfrm>
-          <a:prstGeom prst="rect">
-            <a:avLst/>
-          </a:prstGeom>
-          <a:noFill/>
-          <a:ln/>
-        </p:spPr>
-        <p:txBody>
-          <a:bodyPr wrap="none" lIns="0" tIns="0" rIns="0" bIns="0" rtlCol="0" anchor="ctr"/>
-          <a:lstStyle/>
-          <a:p>
-            <a:pPr algn="ctr" indent="0" marL="0">
-              <a:buNone/>
-            </a:pPr>
-            <a:r>
-              <a:rPr lang="ko-KR" altLang="en-US" sz="1200" spc="-30" kern="0" dirty="0">
-                <a:solidFill>
-                  <a:srgbClr val="4B5568"/>
-                </a:solidFill>
-                <a:latin typeface="Paperlogy 5 Medium" pitchFamily="34" charset="0"/>
-                <a:ea typeface="Paperlogy 5 Medium" pitchFamily="34" charset="-127"/>
-                <a:cs typeface="Paperlogy 5 Medium" pitchFamily="34" charset="-120"/>
-              </a:rPr>
-              <a:t>유닛 모듈러 설계 ·</a:t>
-            </a:r>
-            <a:endParaRPr lang="en-US" sz="1200" dirty="0"/>
-          </a:p>
-        </p:txBody>
-      </p:sp>
-      <p:sp>
-        <p:nvSpPr>
-          <p:cNvPr id="65" name="배치계획"/>
-          <p:cNvSpPr txBox="1"/>
-          <p:nvPr/>
-        </p:nvSpPr>
-        <p:spPr>
-          <a:xfrm>
-            <a:off x="4721920" y="4503837"/>
-            <a:ext cx="572095" cy="177800"/>
-          </a:xfrm>
-          <a:prstGeom prst="rect">
-            <a:avLst/>
-          </a:prstGeom>
-          <a:noFill/>
-          <a:ln/>
-        </p:spPr>
-        <p:txBody>
-          <a:bodyPr wrap="none" lIns="0" tIns="0" rIns="0" bIns="0" rtlCol="0" anchor="ctr"/>
-          <a:lstStyle/>
-          <a:p>
-            <a:pPr algn="ctr" indent="0" marL="0">
-              <a:buNone/>
-            </a:pPr>
-            <a:r>
-              <a:rPr lang="ko-KR" altLang="en-US" sz="1200" spc="-30" kern="0" dirty="0">
-                <a:solidFill>
-                  <a:srgbClr val="4B5568"/>
-                </a:solidFill>
-                <a:latin typeface="Paperlogy 5 Medium" pitchFamily="34" charset="0"/>
-                <a:ea typeface="Paperlogy 5 Medium" pitchFamily="34" charset="-127"/>
-                <a:cs typeface="Paperlogy 5 Medium" pitchFamily="34" charset="-120"/>
-              </a:rPr>
-              <a:t>배치계획</a:t>
-            </a:r>
-            <a:endParaRPr lang="en-US" sz="1200" dirty="0"/>
-          </a:p>
-        </p:txBody>
-      </p:sp>
-      <p:sp>
-        <p:nvSpPr>
-          <p:cNvPr id="66" name="팀원 B"/>
-          <p:cNvSpPr txBox="1"/>
-          <p:nvPr/>
-        </p:nvSpPr>
-        <p:spPr>
-          <a:xfrm>
-            <a:off x="6196905" y="4068366"/>
-            <a:ext cx="458391" cy="177800"/>
-          </a:xfrm>
-          <a:prstGeom prst="rect">
-            <a:avLst/>
-          </a:prstGeom>
-          <a:noFill/>
-          <a:ln/>
-        </p:spPr>
-        <p:txBody>
-          <a:bodyPr wrap="none" lIns="0" tIns="0" rIns="0" bIns="0" rtlCol="0" anchor="ctr"/>
-          <a:lstStyle/>
-          <a:p>
-            <a:pPr algn="ctr" indent="0" marL="0">
-              <a:buNone/>
-            </a:pPr>
-            <a:r>
-              <a:rPr lang="ko-KR" altLang="en-US" sz="1200" spc="-24" kern="0" dirty="0">
-                <a:solidFill>
-                  <a:srgbClr val="0B2147"/>
-                </a:solidFill>
-                <a:latin typeface="Paperlogy 8 ExtraBold" pitchFamily="34" charset="0"/>
-                <a:ea typeface="Paperlogy 8 ExtraBold" pitchFamily="34" charset="-127"/>
-                <a:cs typeface="Paperlogy 8 ExtraBold" pitchFamily="34" charset="-120"/>
-              </a:rPr>
-              <a:t>팀원 B</a:t>
-            </a:r>
-            <a:endParaRPr lang="en-US" sz="1200" dirty="0"/>
-          </a:p>
-        </p:txBody>
-      </p:sp>
-      <p:sp>
-        <p:nvSpPr>
-          <p:cNvPr id="67" name="Revit 기반"/>
-          <p:cNvSpPr txBox="1"/>
-          <p:nvPr/>
-        </p:nvSpPr>
-        <p:spPr>
-          <a:xfrm>
-            <a:off x="5992912" y="4298156"/>
-            <a:ext cx="713978" cy="177800"/>
-          </a:xfrm>
-          <a:prstGeom prst="rect">
-            <a:avLst/>
-          </a:prstGeom>
-          <a:noFill/>
-          <a:ln/>
-        </p:spPr>
-        <p:txBody>
-          <a:bodyPr wrap="none" lIns="0" tIns="0" rIns="0" bIns="0" rtlCol="0" anchor="ctr"/>
-          <a:lstStyle/>
-          <a:p>
-            <a:pPr algn="ctr" indent="0" marL="0">
-              <a:buNone/>
-            </a:pPr>
-            <a:r>
-              <a:rPr lang="ko-KR" altLang="en-US" sz="1200" spc="-30" kern="0" dirty="0">
-                <a:solidFill>
-                  <a:srgbClr val="4B5568"/>
-                </a:solidFill>
-                <a:latin typeface="Paperlogy 5 Medium" pitchFamily="34" charset="0"/>
-                <a:ea typeface="Paperlogy 5 Medium" pitchFamily="34" charset="-127"/>
-                <a:cs typeface="Paperlogy 5 Medium" pitchFamily="34" charset="-120"/>
-              </a:rPr>
-              <a:t>Revit 기반</a:t>
-            </a:r>
-            <a:endParaRPr lang="en-US" sz="1200" dirty="0"/>
-          </a:p>
-        </p:txBody>
-      </p:sp>
-      <p:sp>
-        <p:nvSpPr>
-          <p:cNvPr id="68" name="BIM 모델링 ·"/>
-          <p:cNvSpPr txBox="1"/>
-          <p:nvPr/>
-        </p:nvSpPr>
-        <p:spPr>
-          <a:xfrm>
-            <a:off x="5930404" y="4503837"/>
-            <a:ext cx="838994" cy="177800"/>
-          </a:xfrm>
-          <a:prstGeom prst="rect">
-            <a:avLst/>
-          </a:prstGeom>
-          <a:noFill/>
-          <a:ln/>
-        </p:spPr>
-        <p:txBody>
-          <a:bodyPr wrap="none" lIns="0" tIns="0" rIns="0" bIns="0" rtlCol="0" anchor="ctr"/>
-          <a:lstStyle/>
-          <a:p>
-            <a:pPr algn="ctr" indent="0" marL="0">
-              <a:buNone/>
-            </a:pPr>
-            <a:r>
-              <a:rPr lang="ko-KR" altLang="en-US" sz="1200" spc="-30" kern="0" dirty="0">
-                <a:solidFill>
-                  <a:srgbClr val="4B5568"/>
-                </a:solidFill>
-                <a:latin typeface="Paperlogy 5 Medium" pitchFamily="34" charset="0"/>
-                <a:ea typeface="Paperlogy 5 Medium" pitchFamily="34" charset="-127"/>
-                <a:cs typeface="Paperlogy 5 Medium" pitchFamily="34" charset="-120"/>
-              </a:rPr>
-              <a:t>BIM 모델링 ·</a:t>
-            </a:r>
-            <a:endParaRPr lang="en-US" sz="1200" dirty="0"/>
-          </a:p>
-        </p:txBody>
-      </p:sp>
-      <p:sp>
-        <p:nvSpPr>
-          <p:cNvPr id="69" name="데이터 구축"/>
-          <p:cNvSpPr txBox="1"/>
-          <p:nvPr/>
-        </p:nvSpPr>
-        <p:spPr>
-          <a:xfrm>
-            <a:off x="5983883" y="4709517"/>
-            <a:ext cx="732036" cy="177800"/>
-          </a:xfrm>
-          <a:prstGeom prst="rect">
-            <a:avLst/>
-          </a:prstGeom>
-          <a:noFill/>
-          <a:ln/>
-        </p:spPr>
-        <p:txBody>
-          <a:bodyPr wrap="none" lIns="0" tIns="0" rIns="0" bIns="0" rtlCol="0" anchor="ctr"/>
-          <a:lstStyle/>
-          <a:p>
-            <a:pPr algn="ctr" indent="0" marL="0">
-              <a:buNone/>
-            </a:pPr>
-            <a:r>
-              <a:rPr lang="ko-KR" altLang="en-US" sz="1200" spc="-30" kern="0" dirty="0">
-                <a:solidFill>
-                  <a:srgbClr val="4B5568"/>
-                </a:solidFill>
-                <a:latin typeface="Paperlogy 5 Medium" pitchFamily="34" charset="0"/>
-                <a:ea typeface="Paperlogy 5 Medium" pitchFamily="34" charset="-127"/>
-                <a:cs typeface="Paperlogy 5 Medium" pitchFamily="34" charset="-120"/>
-              </a:rPr>
-              <a:t>데이터 구축</a:t>
-            </a:r>
-            <a:endParaRPr lang="en-US" sz="1200" dirty="0"/>
-          </a:p>
-        </p:txBody>
-      </p:sp>
-      <p:sp>
-        <p:nvSpPr>
-          <p:cNvPr id="70" name="팀원 C"/>
-          <p:cNvSpPr txBox="1"/>
-          <p:nvPr/>
-        </p:nvSpPr>
-        <p:spPr>
-          <a:xfrm>
-            <a:off x="7541419" y="4068366"/>
-            <a:ext cx="453231" cy="177800"/>
-          </a:xfrm>
-          <a:prstGeom prst="rect">
-            <a:avLst/>
-          </a:prstGeom>
-          <a:noFill/>
-          <a:ln/>
-        </p:spPr>
-        <p:txBody>
-          <a:bodyPr wrap="none" lIns="0" tIns="0" rIns="0" bIns="0" rtlCol="0" anchor="ctr"/>
-          <a:lstStyle/>
-          <a:p>
-            <a:pPr algn="ctr" indent="0" marL="0">
-              <a:buNone/>
-            </a:pPr>
-            <a:r>
-              <a:rPr lang="ko-KR" altLang="en-US" sz="1200" spc="-24" kern="0" dirty="0">
-                <a:solidFill>
-                  <a:srgbClr val="0B2147"/>
-                </a:solidFill>
-                <a:latin typeface="Paperlogy 8 ExtraBold" pitchFamily="34" charset="0"/>
-                <a:ea typeface="Paperlogy 8 ExtraBold" pitchFamily="34" charset="-127"/>
-                <a:cs typeface="Paperlogy 8 ExtraBold" pitchFamily="34" charset="-120"/>
-              </a:rPr>
-              <a:t>팀원 C</a:t>
-            </a:r>
-            <a:endParaRPr lang="en-US" sz="1200" dirty="0"/>
-          </a:p>
-        </p:txBody>
-      </p:sp>
-      <p:sp>
-        <p:nvSpPr>
-          <p:cNvPr id="71" name="리모델링 적용"/>
-          <p:cNvSpPr txBox="1"/>
-          <p:nvPr/>
-        </p:nvSpPr>
-        <p:spPr>
-          <a:xfrm>
-            <a:off x="7260630" y="4298156"/>
-            <a:ext cx="862409" cy="177800"/>
-          </a:xfrm>
-          <a:prstGeom prst="rect">
-            <a:avLst/>
-          </a:prstGeom>
-          <a:noFill/>
-          <a:ln/>
-        </p:spPr>
-        <p:txBody>
-          <a:bodyPr wrap="none" lIns="0" tIns="0" rIns="0" bIns="0" rtlCol="0" anchor="ctr"/>
-          <a:lstStyle/>
-          <a:p>
-            <a:pPr algn="ctr" indent="0" marL="0">
-              <a:buNone/>
-            </a:pPr>
-            <a:r>
-              <a:rPr lang="ko-KR" altLang="en-US" sz="1200" spc="-30" kern="0" dirty="0">
-                <a:solidFill>
-                  <a:srgbClr val="4B5568"/>
-                </a:solidFill>
-                <a:latin typeface="Paperlogy 5 Medium" pitchFamily="34" charset="0"/>
-                <a:ea typeface="Paperlogy 5 Medium" pitchFamily="34" charset="-127"/>
-                <a:cs typeface="Paperlogy 5 Medium" pitchFamily="34" charset="-120"/>
-              </a:rPr>
-              <a:t>리모델링 적용</a:t>
-            </a:r>
-            <a:endParaRPr lang="en-US" sz="1200" dirty="0"/>
-          </a:p>
-        </p:txBody>
-      </p:sp>
-      <p:sp>
-        <p:nvSpPr>
-          <p:cNvPr id="72" name="시나리오 구성 ·"/>
-          <p:cNvSpPr txBox="1"/>
-          <p:nvPr/>
-        </p:nvSpPr>
-        <p:spPr>
-          <a:xfrm>
-            <a:off x="7224132" y="4503837"/>
-            <a:ext cx="935504" cy="177800"/>
-          </a:xfrm>
-          <a:prstGeom prst="rect">
-            <a:avLst/>
-          </a:prstGeom>
-          <a:noFill/>
-          <a:ln/>
-        </p:spPr>
-        <p:txBody>
-          <a:bodyPr wrap="none" lIns="0" tIns="0" rIns="0" bIns="0" rtlCol="0" anchor="ctr"/>
-          <a:lstStyle/>
-          <a:p>
-            <a:pPr algn="ctr" indent="0" marL="0">
-              <a:buNone/>
-            </a:pPr>
-            <a:r>
-              <a:rPr lang="ko-KR" altLang="en-US" sz="1200" spc="-30" kern="0" dirty="0">
-                <a:solidFill>
-                  <a:srgbClr val="4B5568"/>
-                </a:solidFill>
-                <a:latin typeface="Paperlogy 5 Medium" pitchFamily="34" charset="0"/>
-                <a:ea typeface="Paperlogy 5 Medium" pitchFamily="34" charset="-127"/>
-                <a:cs typeface="Paperlogy 5 Medium" pitchFamily="34" charset="-120"/>
-              </a:rPr>
-              <a:t>시나리오 구성 ·</a:t>
-            </a:r>
-            <a:endParaRPr lang="en-US" sz="1200" dirty="0"/>
-          </a:p>
-        </p:txBody>
-      </p:sp>
-      <p:sp>
-        <p:nvSpPr>
-          <p:cNvPr id="73" name="시연 영상 제작"/>
-          <p:cNvSpPr txBox="1"/>
-          <p:nvPr/>
-        </p:nvSpPr>
-        <p:spPr>
-          <a:xfrm>
-            <a:off x="7245846" y="4709517"/>
-            <a:ext cx="892076" cy="177800"/>
-          </a:xfrm>
-          <a:prstGeom prst="rect">
-            <a:avLst/>
-          </a:prstGeom>
-          <a:noFill/>
-          <a:ln/>
-        </p:spPr>
-        <p:txBody>
-          <a:bodyPr wrap="none" lIns="0" tIns="0" rIns="0" bIns="0" rtlCol="0" anchor="ctr"/>
-          <a:lstStyle/>
-          <a:p>
-            <a:pPr algn="ctr" indent="0" marL="0">
-              <a:buNone/>
-            </a:pPr>
-            <a:r>
-              <a:rPr lang="ko-KR" altLang="en-US" sz="1200" spc="-30" kern="0" dirty="0">
-                <a:solidFill>
-                  <a:srgbClr val="4B5568"/>
-                </a:solidFill>
-                <a:latin typeface="Paperlogy 5 Medium" pitchFamily="34" charset="0"/>
-                <a:ea typeface="Paperlogy 5 Medium" pitchFamily="34" charset="-127"/>
-                <a:cs typeface="Paperlogy 5 Medium" pitchFamily="34" charset="-120"/>
-              </a:rPr>
-              <a:t>시연 영상 제작</a:t>
-            </a:r>
-            <a:endParaRPr lang="en-US" sz="1200" dirty="0"/>
-          </a:p>
-        </p:txBody>
-      </p:sp>
-      <p:sp>
-        <p:nvSpPr>
-          <p:cNvPr id="74" name="이틀마다 진행상황 공유 · 피드백"/>
-          <p:cNvSpPr txBox="1"/>
-          <p:nvPr/>
-        </p:nvSpPr>
-        <p:spPr>
-          <a:xfrm>
-            <a:off x="5528370" y="5304234"/>
-            <a:ext cx="1984173" cy="177800"/>
-          </a:xfrm>
-          <a:prstGeom prst="rect">
-            <a:avLst/>
-          </a:prstGeom>
-          <a:noFill/>
-          <a:ln/>
-        </p:spPr>
-        <p:txBody>
-          <a:bodyPr wrap="none" lIns="0" tIns="0" rIns="0" bIns="0" rtlCol="0" anchor="ctr"/>
-          <a:lstStyle/>
-          <a:p>
-            <a:pPr algn="l" indent="0" marL="0">
-              <a:buNone/>
-            </a:pPr>
-            <a:r>
-              <a:rPr lang="ko-KR" altLang="en-US" sz="1200" spc="-24" kern="0" dirty="0">
-                <a:solidFill>
-                  <a:srgbClr val="0B2147"/>
-                </a:solidFill>
-                <a:latin typeface="Paperlogy 7 Bold" pitchFamily="34" charset="0"/>
-                <a:ea typeface="Paperlogy 7 Bold" pitchFamily="34" charset="-127"/>
-                <a:cs typeface="Paperlogy 7 Bold" pitchFamily="34" charset="-120"/>
-              </a:rPr>
-              <a:t>이틀마다 진행상황 공유 · 피드백</a:t>
-            </a:r>
-            <a:endParaRPr lang="en-US" sz="1200" dirty="0"/>
-          </a:p>
-        </p:txBody>
-      </p:sp>
-      <p:sp>
-        <p:nvSpPr>
-          <p:cNvPr id="75" name="리모델링 앱 개발 아이디어 시연 영상"/>
-          <p:cNvSpPr txBox="1"/>
-          <p:nvPr/>
-        </p:nvSpPr>
-        <p:spPr>
-          <a:xfrm>
-            <a:off x="9239200" y="3497064"/>
-            <a:ext cx="1871323" cy="152400"/>
-          </a:xfrm>
-          <a:prstGeom prst="rect">
-            <a:avLst/>
-          </a:prstGeom>
-          <a:noFill/>
-          <a:ln/>
-        </p:spPr>
-        <p:txBody>
-          <a:bodyPr wrap="none" lIns="0" tIns="0" rIns="0" bIns="0" rtlCol="0" anchor="ctr"/>
-          <a:lstStyle/>
-          <a:p>
-            <a:pPr algn="l" indent="0" marL="0">
-              <a:buNone/>
-            </a:pPr>
-            <a:r>
-              <a:rPr lang="ko-KR" altLang="en-US" sz="1000" spc="-20" kern="0" dirty="0">
-                <a:solidFill>
-                  <a:srgbClr val="4B5568"/>
-                </a:solidFill>
-                <a:latin typeface="Paperlogy 6 SemiBold" pitchFamily="34" charset="0"/>
-                <a:ea typeface="Paperlogy 6 SemiBold" pitchFamily="34" charset="-127"/>
-                <a:cs typeface="Paperlogy 6 SemiBold" pitchFamily="34" charset="-120"/>
-              </a:rPr>
-              <a:t>리모델링 앱 개발 아이디어 시연 영상</a:t>
-            </a:r>
-            <a:endParaRPr lang="en-US" sz="1000" dirty="0"/>
-          </a:p>
-        </p:txBody>
-      </p:sp>
-      <p:sp>
-        <p:nvSpPr>
-          <p:cNvPr id="76" name="장려상"/>
-          <p:cNvSpPr txBox="1"/>
-          <p:nvPr/>
-        </p:nvSpPr>
-        <p:spPr>
-          <a:xfrm>
-            <a:off x="9749433" y="4500364"/>
-            <a:ext cx="795734" cy="342900"/>
-          </a:xfrm>
-          <a:prstGeom prst="rect">
-            <a:avLst/>
-          </a:prstGeom>
-          <a:noFill/>
-          <a:ln/>
-        </p:spPr>
-        <p:txBody>
-          <a:bodyPr wrap="none" lIns="0" tIns="0" rIns="0" bIns="0" rtlCol="0" anchor="ctr"/>
-          <a:lstStyle/>
-          <a:p>
-            <a:pPr algn="l" indent="0" marL="0">
-              <a:buNone/>
-            </a:pPr>
-            <a:r>
-              <a:rPr lang="ko-KR" altLang="en-US" sz="2300" spc="-69" kern="0" dirty="0">
-                <a:solidFill>
-                  <a:srgbClr val="0B2147"/>
-                </a:solidFill>
-                <a:latin typeface="Paperlogy 9 Black" pitchFamily="34" charset="0"/>
-                <a:ea typeface="Paperlogy 9 Black" pitchFamily="34" charset="-127"/>
-                <a:cs typeface="Paperlogy 9 Black" pitchFamily="34" charset="-120"/>
-              </a:rPr>
-              <a:t>장려상</a:t>
-            </a:r>
-            <a:endParaRPr lang="en-US" sz="2300" dirty="0"/>
-          </a:p>
-        </p:txBody>
-      </p:sp>
-      <p:sp>
-        <p:nvSpPr>
-          <p:cNvPr id="77" name="학생 BIM 경진대회 장려상 · 남은 3주 내 완성"/>
-          <p:cNvSpPr txBox="1"/>
-          <p:nvPr/>
-        </p:nvSpPr>
-        <p:spPr>
-          <a:xfrm>
-            <a:off x="9014619" y="5376664"/>
-            <a:ext cx="2347436" cy="152400"/>
-          </a:xfrm>
-          <a:prstGeom prst="rect">
-            <a:avLst/>
-          </a:prstGeom>
-          <a:noFill/>
-          <a:ln/>
-        </p:spPr>
-        <p:txBody>
-          <a:bodyPr wrap="none" lIns="0" tIns="0" rIns="0" bIns="0" rtlCol="0" anchor="ctr"/>
-          <a:lstStyle/>
-          <a:p>
-            <a:pPr algn="l" indent="0" marL="0">
-              <a:buNone/>
-            </a:pPr>
-            <a:r>
-              <a:rPr lang="ko-KR" altLang="en-US" sz="1000" spc="-20" kern="0" dirty="0">
-                <a:solidFill>
-                  <a:srgbClr val="0B2147"/>
-                </a:solidFill>
-                <a:latin typeface="Paperlogy 7 Bold" pitchFamily="34" charset="0"/>
-                <a:ea typeface="Paperlogy 7 Bold" pitchFamily="34" charset="-127"/>
-                <a:cs typeface="Paperlogy 7 Bold" pitchFamily="34" charset="-120"/>
-              </a:rPr>
-              <a:t>학생 BIM 경진대회 장려상 · 남은 3주 내 완성</a:t>
-            </a:r>
-            <a:endParaRPr lang="en-US" sz="1000" dirty="0"/>
-          </a:p>
-        </p:txBody>
-      </p:sp>
-      <p:sp>
-        <p:nvSpPr>
-          <p:cNvPr id="78" name="KEY MESSAGE"/>
-          <p:cNvSpPr txBox="1"/>
-          <p:nvPr/>
-        </p:nvSpPr>
-        <p:spPr>
-          <a:xfrm>
-            <a:off x="1308100" y="6007298"/>
-            <a:ext cx="1171825" cy="146050"/>
-          </a:xfrm>
-          <a:prstGeom prst="rect">
-            <a:avLst/>
-          </a:prstGeom>
-          <a:noFill/>
-          <a:ln/>
-        </p:spPr>
-        <p:txBody>
-          <a:bodyPr wrap="none" lIns="0" tIns="0" rIns="0" bIns="0" rtlCol="0" anchor="ctr"/>
-          <a:lstStyle/>
-          <a:p>
-            <a:pPr algn="l" indent="0" marL="0">
-              <a:buNone/>
-            </a:pPr>
-            <a:r>
-              <a:rPr lang="ko-KR" altLang="en-US" sz="950" spc="152" kern="0" dirty="0">
-                <a:solidFill>
-                  <a:srgbClr val="8FD3F5"/>
-                </a:solidFill>
-                <a:latin typeface="Paperlogy 7 Bold" pitchFamily="34" charset="0"/>
-                <a:ea typeface="Paperlogy 7 Bold" pitchFamily="34" charset="-127"/>
-                <a:cs typeface="Paperlogy 7 Bold" pitchFamily="34" charset="-120"/>
-              </a:rPr>
-              <a:t>KEY MESSAGE</a:t>
-            </a:r>
-            <a:endParaRPr lang="en-US" sz="950" dirty="0"/>
-          </a:p>
-        </p:txBody>
-      </p:sp>
-      <p:sp>
-        <p:nvSpPr>
-          <p:cNvPr id="79" name="서로 다른 사람을 하나의 공동 목표로 연결합니다"/>
-          <p:cNvSpPr txBox="1"/>
-          <p:nvPr/>
-        </p:nvSpPr>
-        <p:spPr>
-          <a:xfrm>
-            <a:off x="2591395" y="5954514"/>
-            <a:ext cx="4151660" cy="254000"/>
-          </a:xfrm>
-          <a:prstGeom prst="rect">
-            <a:avLst/>
-          </a:prstGeom>
-          <a:noFill/>
-          <a:ln/>
-        </p:spPr>
-        <p:txBody>
-          <a:bodyPr wrap="none" lIns="0" tIns="0" rIns="0" bIns="0" rtlCol="0" anchor="ctr"/>
-          <a:lstStyle/>
-          <a:p>
-            <a:pPr algn="l" indent="0" marL="0">
-              <a:buNone/>
-            </a:pPr>
-            <a:r>
-              <a:rPr lang="ko-KR" altLang="en-US" sz="1700" spc="-51" kern="0" dirty="0">
-                <a:solidFill>
-                  <a:srgbClr val="FFFFFF"/>
-                </a:solidFill>
-                <a:latin typeface="Paperlogy 7 Bold" pitchFamily="34" charset="0"/>
-                <a:ea typeface="Paperlogy 7 Bold" pitchFamily="34" charset="-127"/>
-                <a:cs typeface="Paperlogy 7 Bold" pitchFamily="34" charset="-120"/>
-              </a:rPr>
-              <a:t>서로 다른 사람을 </a:t>
-            </a:r>
-            <a:pPr algn="l" indent="0" marL="0">
-              <a:buNone/>
-            </a:pPr>
-            <a:r>
-              <a:rPr lang="ko-KR" altLang="en-US" sz="1700" spc="-51" kern="0" dirty="0">
-                <a:solidFill>
-                  <a:srgbClr val="FDBB30"/>
-                </a:solidFill>
-                <a:latin typeface="Paperlogy 7 Bold" pitchFamily="34" charset="0"/>
-                <a:ea typeface="Paperlogy 7 Bold" pitchFamily="34" charset="-127"/>
-                <a:cs typeface="Paperlogy 7 Bold" pitchFamily="34" charset="-120"/>
-              </a:rPr>
-              <a:t>하나의 공동 목표</a:t>
-            </a:r>
-            <a:pPr algn="l" indent="0" marL="0">
-              <a:buNone/>
-            </a:pPr>
-            <a:r>
-              <a:rPr lang="ko-KR" altLang="en-US" sz="1700" spc="-51" kern="0" dirty="0">
-                <a:solidFill>
-                  <a:srgbClr val="FFFFFF"/>
-                </a:solidFill>
-                <a:latin typeface="Paperlogy 7 Bold" pitchFamily="34" charset="0"/>
-                <a:ea typeface="Paperlogy 7 Bold" pitchFamily="34" charset="-127"/>
-                <a:cs typeface="Paperlogy 7 Bold" pitchFamily="34" charset="-120"/>
-              </a:rPr>
-              <a:t>로 연결합니다</a:t>
-            </a:r>
-            <a:endParaRPr lang="en-US" sz="1700" dirty="0"/>
-          </a:p>
-        </p:txBody>
-      </p:sp>
-      <p:sp>
-        <p:nvSpPr>
-          <p:cNvPr id="80" name="2026년 하반기 신입사원 공개채용"/>
-          <p:cNvSpPr txBox="1"/>
-          <p:nvPr/>
-        </p:nvSpPr>
-        <p:spPr>
-          <a:xfrm>
-            <a:off x="609600" y="6425605"/>
-            <a:ext cx="1659507" cy="139700"/>
-          </a:xfrm>
-          <a:prstGeom prst="rect">
-            <a:avLst/>
-          </a:prstGeom>
-          <a:noFill/>
-          <a:ln/>
-        </p:spPr>
-        <p:txBody>
-          <a:bodyPr wrap="none" lIns="0" tIns="0" rIns="0" bIns="0" rtlCol="0" anchor="ctr"/>
-          <a:lstStyle/>
-          <a:p>
-            <a:pPr algn="l" indent="0" marL="0">
-              <a:buNone/>
-            </a:pPr>
-            <a:r>
-              <a:rPr lang="ko-KR" altLang="en-US" sz="900" spc="-9" kern="0" dirty="0">
-                <a:solidFill>
-                  <a:srgbClr val="8691A5"/>
-                </a:solidFill>
-                <a:latin typeface="Paperlogy 5 Medium" pitchFamily="34" charset="0"/>
-                <a:ea typeface="Paperlogy 5 Medium" pitchFamily="34" charset="-127"/>
-                <a:cs typeface="Paperlogy 5 Medium" pitchFamily="34" charset="-120"/>
-              </a:rPr>
               <a:t>2026년 하반기 신입사원 공개채용</a:t>
             </a:r>
             <a:endParaRPr lang="en-US" sz="900" dirty="0"/>
@@ -3586,7 +3736,7 @@
       </p:sp>
       <p:sp>
         <p:nvSpPr>
-          <p:cNvPr id="81" name="01 / 03"/>
+          <p:cNvPr id="87" name="01 / 03"/>
           <p:cNvSpPr txBox="1"/>
           <p:nvPr/>
         </p:nvSpPr>

</xml_diff>

<commit_message>
Show team roles as a round table around the shared goal
Block 02 on slide 1 drops the top-down org tree: the leader and members
A/B/C sit as equal-sized cards around a central 공동 목표 node, joined by
spokes and a circulating ring for the every-two-days check-in. The leader
is marked only by colour and a 나 tag. HTML, PDF, previews and PPTX
rebuilt.

Co-Authored-By: Claude Opus 5.5 <noreply@anthropic.com>
Claude-Session: https://claude.ai/code/session_01D2YY6No1o1YF3BX8eJSF6k
</commit_message>
<xml_diff>
--- a/hec-pt/pptx/landscape.pptx
+++ b/hec-pt/pptx/landscape.pptx
@@ -1567,51 +1567,9 @@
           <a:ln/>
         </p:spPr>
       </p:sp>
-      <p:sp>
-        <p:nvSpPr>
-          <p:cNvPr id="25" name="p1-lead"/>
-          <p:cNvSpPr/>
-          <p:nvPr/>
-        </p:nvSpPr>
-        <p:spPr>
-          <a:xfrm>
-            <a:off x="5061148" y="2576314"/>
-            <a:ext cx="2577604" cy="863402"/>
-          </a:xfrm>
-          <a:prstGeom prst="roundRect">
-            <a:avLst>
-              <a:gd name="adj" fmla="val 13238"/>
-            </a:avLst>
-          </a:prstGeom>
-          <a:solidFill>
-            <a:srgbClr val="0B2147"/>
-          </a:solidFill>
-          <a:ln/>
-        </p:spPr>
-      </p:sp>
-      <p:sp>
-        <p:nvSpPr>
-          <p:cNvPr id="26" name="p1-av"/>
-          <p:cNvSpPr/>
-          <p:nvPr/>
-        </p:nvSpPr>
-        <p:spPr>
-          <a:xfrm>
-            <a:off x="6022578" y="2745184"/>
-            <a:ext cx="88900" cy="88900"/>
-          </a:xfrm>
-          <a:prstGeom prst="ellipse">
-            <a:avLst/>
-          </a:prstGeom>
-          <a:solidFill>
-            <a:srgbClr val="00A94F"/>
-          </a:solidFill>
-          <a:ln/>
-        </p:spPr>
-      </p:sp>
       <p:pic>
         <p:nvPicPr>
-          <p:cNvPr id="27" name="p1-tree" descr="p1-tree">    </p:cNvPr>
+          <p:cNvPr id="25" name="svg" descr="svg">    </p:cNvPr>
           <p:cNvPicPr>
             <a:picLocks noChangeAspect="1"/>
           </p:cNvPicPr>
@@ -1625,8 +1583,8 @@
         </p:blipFill>
         <p:spPr>
           <a:xfrm>
-            <a:off x="4997450" y="3431249"/>
-            <a:ext cx="2705100" cy="541867"/>
+            <a:off x="5063067" y="2974247"/>
+            <a:ext cx="2573867" cy="2192867"/>
           </a:xfrm>
           <a:prstGeom prst="rect">
             <a:avLst/>
@@ -1635,18 +1593,85 @@
       </p:pic>
       <p:sp>
         <p:nvSpPr>
-          <p:cNvPr id="28" name="p1-mem"/>
-          <p:cNvSpPr/>
-          <p:nvPr/>
-        </p:nvSpPr>
-        <p:spPr>
-          <a:xfrm>
-            <a:off x="4387850" y="3966766"/>
-            <a:ext cx="1240334" cy="1030982"/>
+          <p:cNvPr id="26" name="p1-card me"/>
+          <p:cNvSpPr/>
+          <p:nvPr/>
+        </p:nvSpPr>
+        <p:spPr>
+          <a:xfrm>
+            <a:off x="5638800" y="2519164"/>
+            <a:ext cx="1422400" cy="927100"/>
           </a:xfrm>
           <a:prstGeom prst="roundRect">
             <a:avLst>
-              <a:gd name="adj" fmla="val 10471"/>
+              <a:gd name="adj" fmla="val 11644"/>
+            </a:avLst>
+          </a:prstGeom>
+          <a:solidFill>
+            <a:srgbClr val="0B2147"/>
+          </a:solidFill>
+          <a:ln w="12700">
+            <a:solidFill>
+              <a:srgbClr val="0B2147"/>
+            </a:solidFill>
+            <a:prstDash val="solid"/>
+          </a:ln>
+        </p:spPr>
+      </p:sp>
+      <p:sp>
+        <p:nvSpPr>
+          <p:cNvPr id="27" name="p1-av"/>
+          <p:cNvSpPr/>
+          <p:nvPr/>
+        </p:nvSpPr>
+        <p:spPr>
+          <a:xfrm>
+            <a:off x="6022082" y="2633365"/>
+            <a:ext cx="88900" cy="88900"/>
+          </a:xfrm>
+          <a:prstGeom prst="ellipse">
+            <a:avLst/>
+          </a:prstGeom>
+          <a:solidFill>
+            <a:srgbClr val="00A94F"/>
+          </a:solidFill>
+          <a:ln/>
+        </p:spPr>
+      </p:sp>
+      <p:sp>
+        <p:nvSpPr>
+          <p:cNvPr id="28" name="p1-me"/>
+          <p:cNvSpPr/>
+          <p:nvPr/>
+        </p:nvSpPr>
+        <p:spPr>
+          <a:xfrm>
+            <a:off x="6500118" y="2588915"/>
+            <a:ext cx="177800" cy="177800"/>
+          </a:xfrm>
+          <a:prstGeom prst="ellipse">
+            <a:avLst/>
+          </a:prstGeom>
+          <a:solidFill>
+            <a:srgbClr val="FFFFFF"/>
+          </a:solidFill>
+          <a:ln/>
+        </p:spPr>
+      </p:sp>
+      <p:sp>
+        <p:nvSpPr>
+          <p:cNvPr id="29" name="p1-card"/>
+          <p:cNvSpPr/>
+          <p:nvPr/>
+        </p:nvSpPr>
+        <p:spPr>
+          <a:xfrm>
+            <a:off x="6915150" y="3605014"/>
+            <a:ext cx="1422400" cy="927100"/>
+          </a:xfrm>
+          <a:prstGeom prst="roundRect">
+            <a:avLst>
+              <a:gd name="adj" fmla="val 11644"/>
             </a:avLst>
           </a:prstGeom>
           <a:solidFill>
@@ -1662,13 +1687,13 @@
       </p:sp>
       <p:sp>
         <p:nvSpPr>
-          <p:cNvPr id="29" name="p1-av"/>
-          <p:cNvSpPr/>
-          <p:nvPr/>
-        </p:nvSpPr>
-        <p:spPr>
-          <a:xfrm>
-            <a:off x="4727873" y="4116586"/>
+          <p:cNvPr id="30" name="p1-av"/>
+          <p:cNvSpPr/>
+          <p:nvPr/>
+        </p:nvSpPr>
+        <p:spPr>
+          <a:xfrm>
+            <a:off x="7346255" y="3814465"/>
             <a:ext cx="88900" cy="88900"/>
           </a:xfrm>
           <a:prstGeom prst="ellipse">
@@ -1682,18 +1707,18 @@
       </p:sp>
       <p:sp>
         <p:nvSpPr>
-          <p:cNvPr id="30" name="p1-mem"/>
-          <p:cNvSpPr/>
-          <p:nvPr/>
-        </p:nvSpPr>
-        <p:spPr>
-          <a:xfrm>
-            <a:off x="5729784" y="3966766"/>
-            <a:ext cx="1240334" cy="1030982"/>
+          <p:cNvPr id="31" name="p1-card"/>
+          <p:cNvSpPr/>
+          <p:nvPr/>
+        </p:nvSpPr>
+        <p:spPr>
+          <a:xfrm>
+            <a:off x="5638800" y="4690864"/>
+            <a:ext cx="1422400" cy="927100"/>
           </a:xfrm>
           <a:prstGeom prst="roundRect">
             <a:avLst>
-              <a:gd name="adj" fmla="val 10471"/>
+              <a:gd name="adj" fmla="val 11644"/>
             </a:avLst>
           </a:prstGeom>
           <a:solidFill>
@@ -1709,13 +1734,13 @@
       </p:sp>
       <p:sp>
         <p:nvSpPr>
-          <p:cNvPr id="31" name="p1-av"/>
-          <p:cNvSpPr/>
-          <p:nvPr/>
-        </p:nvSpPr>
-        <p:spPr>
-          <a:xfrm>
-            <a:off x="6069905" y="4116586"/>
+          <p:cNvPr id="32" name="p1-av"/>
+          <p:cNvSpPr/>
+          <p:nvPr/>
+        </p:nvSpPr>
+        <p:spPr>
+          <a:xfrm>
+            <a:off x="6070005" y="4805065"/>
             <a:ext cx="88900" cy="88900"/>
           </a:xfrm>
           <a:prstGeom prst="ellipse">
@@ -1729,18 +1754,18 @@
       </p:sp>
       <p:sp>
         <p:nvSpPr>
-          <p:cNvPr id="32" name="p1-mem"/>
-          <p:cNvSpPr/>
-          <p:nvPr/>
-        </p:nvSpPr>
-        <p:spPr>
-          <a:xfrm>
-            <a:off x="7071717" y="3966766"/>
-            <a:ext cx="1240334" cy="1030982"/>
+          <p:cNvPr id="33" name="p1-card"/>
+          <p:cNvSpPr/>
+          <p:nvPr/>
+        </p:nvSpPr>
+        <p:spPr>
+          <a:xfrm>
+            <a:off x="4362450" y="3605014"/>
+            <a:ext cx="1422400" cy="927100"/>
           </a:xfrm>
           <a:prstGeom prst="roundRect">
             <a:avLst>
-              <a:gd name="adj" fmla="val 10471"/>
+              <a:gd name="adj" fmla="val 11644"/>
             </a:avLst>
           </a:prstGeom>
           <a:solidFill>
@@ -1756,13 +1781,13 @@
       </p:sp>
       <p:sp>
         <p:nvSpPr>
-          <p:cNvPr id="33" name="p1-av"/>
-          <p:cNvSpPr/>
-          <p:nvPr/>
-        </p:nvSpPr>
-        <p:spPr>
-          <a:xfrm>
-            <a:off x="7414419" y="4116586"/>
+          <p:cNvPr id="34" name="p1-av"/>
+          <p:cNvSpPr/>
+          <p:nvPr/>
+        </p:nvSpPr>
+        <p:spPr>
+          <a:xfrm>
+            <a:off x="4796234" y="3719215"/>
             <a:ext cx="88900" cy="88900"/>
           </a:xfrm>
           <a:prstGeom prst="ellipse">
@@ -1770,13 +1795,62 @@
           </a:prstGeom>
           <a:solidFill>
             <a:srgbClr val="00A94F"/>
+          </a:solidFill>
+          <a:ln/>
+        </p:spPr>
+      </p:sp>
+      <p:sp>
+        <p:nvSpPr>
+          <p:cNvPr id="35" name="p1-share"/>
+          <p:cNvSpPr/>
+          <p:nvPr/>
+        </p:nvSpPr>
+        <p:spPr>
+          <a:xfrm>
+            <a:off x="7131050" y="4754364"/>
+            <a:ext cx="1115120" cy="444500"/>
+          </a:xfrm>
+          <a:prstGeom prst="roundRect">
+            <a:avLst>
+              <a:gd name="adj" fmla="val 21429"/>
+            </a:avLst>
+          </a:prstGeom>
+          <a:solidFill>
+            <a:srgbClr val="E5F6EC"/>
+          </a:solidFill>
+          <a:ln w="12700">
+            <a:solidFill>
+              <a:srgbClr val="FFFFFF"/>
+            </a:solidFill>
+            <a:prstDash val="solid"/>
+          </a:ln>
+        </p:spPr>
+      </p:sp>
+      <p:sp>
+        <p:nvSpPr>
+          <p:cNvPr id="36" name="p1-blk p1-b3"/>
+          <p:cNvSpPr/>
+          <p:nvPr/>
+        </p:nvSpPr>
+        <p:spPr>
+          <a:xfrm>
+            <a:off x="8661400" y="2436614"/>
+            <a:ext cx="2921000" cy="3263900"/>
+          </a:xfrm>
+          <a:prstGeom prst="roundRect">
+            <a:avLst>
+              <a:gd name="adj" fmla="val 4783"/>
+            </a:avLst>
+          </a:prstGeom>
+          <a:solidFill>
+            <a:srgbClr val="EEF4FC"/>
           </a:solidFill>
           <a:ln/>
         </p:spPr>
       </p:sp>
       <p:pic>
         <p:nvPicPr>
-          <p:cNvPr id="34" name="svg" descr="svg">    </p:cNvPr>
+          <p:cNvPr id="37" name="svg" descr="svg">    </p:cNvPr>
           <p:cNvPicPr>
             <a:picLocks noChangeAspect="1"/>
           </p:cNvPicPr>
@@ -1790,98 +1864,6 @@
         </p:blipFill>
         <p:spPr>
           <a:xfrm>
-            <a:off x="4997450" y="5004098"/>
-            <a:ext cx="2705100" cy="226483"/>
-          </a:xfrm>
-          <a:prstGeom prst="rect">
-            <a:avLst/>
-          </a:prstGeom>
-        </p:spPr>
-      </p:pic>
-      <p:sp>
-        <p:nvSpPr>
-          <p:cNvPr id="35" name="p1-share"/>
-          <p:cNvSpPr/>
-          <p:nvPr/>
-        </p:nvSpPr>
-        <p:spPr>
-          <a:xfrm>
-            <a:off x="4381500" y="5230614"/>
-            <a:ext cx="3937000" cy="330200"/>
-          </a:xfrm>
-          <a:prstGeom prst="roundRect">
-            <a:avLst>
-              <a:gd name="adj" fmla="val 50000"/>
-            </a:avLst>
-          </a:prstGeom>
-          <a:solidFill>
-            <a:srgbClr val="E5F6EC"/>
-          </a:solidFill>
-          <a:ln/>
-        </p:spPr>
-      </p:sp>
-      <p:pic>
-        <p:nvPicPr>
-          <p:cNvPr id="36" name="svg" descr="svg">    </p:cNvPr>
-          <p:cNvPicPr>
-            <a:picLocks noChangeAspect="1"/>
-          </p:cNvPicPr>
-          <p:nvPr/>
-        </p:nvPicPr>
-        <p:blipFill>
-          <a:blip r:embed="rId8"/>
-          <a:stretch>
-            <a:fillRect/>
-          </a:stretch>
-        </p:blipFill>
-        <p:spPr>
-          <a:xfrm>
-            <a:off x="5325170" y="5330097"/>
-            <a:ext cx="118533" cy="135467"/>
-          </a:xfrm>
-          <a:prstGeom prst="rect">
-            <a:avLst/>
-          </a:prstGeom>
-        </p:spPr>
-      </p:pic>
-      <p:sp>
-        <p:nvSpPr>
-          <p:cNvPr id="37" name="p1-blk p1-b3"/>
-          <p:cNvSpPr/>
-          <p:nvPr/>
-        </p:nvSpPr>
-        <p:spPr>
-          <a:xfrm>
-            <a:off x="8661400" y="2436614"/>
-            <a:ext cx="2921000" cy="3263900"/>
-          </a:xfrm>
-          <a:prstGeom prst="roundRect">
-            <a:avLst>
-              <a:gd name="adj" fmla="val 4783"/>
-            </a:avLst>
-          </a:prstGeom>
-          <a:solidFill>
-            <a:srgbClr val="EEF4FC"/>
-          </a:solidFill>
-          <a:ln/>
-        </p:spPr>
-      </p:sp>
-      <p:pic>
-        <p:nvPicPr>
-          <p:cNvPr id="38" name="svg" descr="svg">    </p:cNvPr>
-          <p:cNvPicPr>
-            <a:picLocks noChangeAspect="1"/>
-          </p:cNvPicPr>
-          <p:nvPr/>
-        </p:nvPicPr>
-        <p:blipFill>
-          <a:blip r:embed="rId9"/>
-          <a:stretch>
-            <a:fillRect/>
-          </a:stretch>
-        </p:blipFill>
-        <p:spPr>
-          <a:xfrm>
             <a:off x="9359900" y="2591131"/>
             <a:ext cx="1524000" cy="2717800"/>
           </a:xfrm>
@@ -1892,7 +1874,7 @@
       </p:pic>
       <p:sp>
         <p:nvSpPr>
-          <p:cNvPr id="39" name="key"/>
+          <p:cNvPr id="38" name="key"/>
           <p:cNvSpPr/>
           <p:nvPr/>
         </p:nvSpPr>
@@ -1914,7 +1896,7 @@
       </p:sp>
       <p:sp>
         <p:nvSpPr>
-          <p:cNvPr id="40" name="i"/>
+          <p:cNvPr id="39" name="i"/>
           <p:cNvSpPr/>
           <p:nvPr/>
         </p:nvSpPr>
@@ -1934,7 +1916,7 @@
       </p:sp>
       <p:sp>
         <p:nvSpPr>
-          <p:cNvPr id="41" name="b"/>
+          <p:cNvPr id="40" name="b"/>
           <p:cNvSpPr/>
           <p:nvPr/>
         </p:nvSpPr>
@@ -1954,7 +1936,7 @@
       </p:sp>
       <p:sp>
         <p:nvSpPr>
-          <p:cNvPr id="42" name="i"/>
+          <p:cNvPr id="41" name="i"/>
           <p:cNvSpPr/>
           <p:nvPr/>
         </p:nvSpPr>
@@ -1974,7 +1956,7 @@
       </p:sp>
       <p:sp>
         <p:nvSpPr>
-          <p:cNvPr id="43" name="b"/>
+          <p:cNvPr id="42" name="b"/>
           <p:cNvSpPr/>
           <p:nvPr/>
         </p:nvSpPr>
@@ -1994,7 +1976,7 @@
       </p:sp>
       <p:sp>
         <p:nvSpPr>
-          <p:cNvPr id="44" name="i"/>
+          <p:cNvPr id="43" name="i"/>
           <p:cNvSpPr/>
           <p:nvPr/>
         </p:nvSpPr>
@@ -2014,7 +1996,7 @@
       </p:sp>
       <p:sp>
         <p:nvSpPr>
-          <p:cNvPr id="45" name="01"/>
+          <p:cNvPr id="44" name="01"/>
           <p:cNvSpPr txBox="1"/>
           <p:nvPr/>
         </p:nvSpPr>
@@ -2053,7 +2035,7 @@
       </p:sp>
       <p:sp>
         <p:nvSpPr>
-          <p:cNvPr id="46" name="PT 주제 1 · 가장 중요하게 생각하는 가치와 실천 경험"/>
+          <p:cNvPr id="45" name="PT 주제 1 · 가장 중요하게 생각하는 가치와 실천 경험"/>
           <p:cNvSpPr txBox="1"/>
           <p:nvPr/>
         </p:nvSpPr>
@@ -2092,7 +2074,7 @@
       </p:sp>
       <p:sp>
         <p:nvSpPr>
-          <p:cNvPr id="47" name="제가 가장 중요하게 생각하는 가치는"/>
+          <p:cNvPr id="46" name="제가 가장 중요하게 생각하는 가치는"/>
           <p:cNvSpPr txBox="1"/>
           <p:nvPr/>
         </p:nvSpPr>
@@ -2131,7 +2113,7 @@
       </p:sp>
       <p:sp>
         <p:nvSpPr>
-          <p:cNvPr id="48" name="공동의 목표를 공유하며 함께 성과를 만드는 협업입니다"/>
+          <p:cNvPr id="47" name="공동의 목표를 공유하며 함께 성과를 만드는 협업입니다"/>
           <p:cNvSpPr txBox="1"/>
           <p:nvPr/>
         </p:nvSpPr>
@@ -2212,7 +2194,7 @@
       </p:sp>
       <p:sp>
         <p:nvSpPr>
-          <p:cNvPr id="49" name="학생 BIM 경진대회 · 4인 팀 팀장"/>
+          <p:cNvPr id="48" name="학생 BIM 경진대회 · 4인 팀 팀장"/>
           <p:cNvSpPr txBox="1"/>
           <p:nvPr/>
         </p:nvSpPr>
@@ -2251,7 +2233,7 @@
       </p:sp>
       <p:sp>
         <p:nvSpPr>
-          <p:cNvPr id="50" name="01"/>
+          <p:cNvPr id="49" name="01"/>
           <p:cNvSpPr txBox="1"/>
           <p:nvPr/>
         </p:nvSpPr>
@@ -2290,7 +2272,7 @@
       </p:sp>
       <p:sp>
         <p:nvSpPr>
-          <p:cNvPr id="51" name="충돌을 조율해 주제를 정하다"/>
+          <p:cNvPr id="50" name="충돌을 조율해 주제를 정하다"/>
           <p:cNvSpPr txBox="1"/>
           <p:nvPr/>
         </p:nvSpPr>
@@ -2329,7 +2311,7 @@
       </p:sp>
       <p:sp>
         <p:nvSpPr>
-          <p:cNvPr id="52" name="02"/>
+          <p:cNvPr id="51" name="02"/>
           <p:cNvSpPr txBox="1"/>
           <p:nvPr/>
         </p:nvSpPr>
@@ -2368,7 +2350,7 @@
       </p:sp>
       <p:sp>
         <p:nvSpPr>
-          <p:cNvPr id="53" name="강점에 맞게 역할을 나누다"/>
+          <p:cNvPr id="52" name="강점에 맞게 역할을 나누다"/>
           <p:cNvSpPr txBox="1"/>
           <p:nvPr/>
         </p:nvSpPr>
@@ -2407,7 +2389,7 @@
       </p:sp>
       <p:sp>
         <p:nvSpPr>
-          <p:cNvPr id="54" name="03"/>
+          <p:cNvPr id="53" name="03"/>
           <p:cNvSpPr txBox="1"/>
           <p:nvPr/>
         </p:nvSpPr>
@@ -2446,7 +2428,7 @@
       </p:sp>
       <p:sp>
         <p:nvSpPr>
-          <p:cNvPr id="55" name="3주 만에 완성, 장려상"/>
+          <p:cNvPr id="54" name="3주 만에 완성, 장려상"/>
           <p:cNvSpPr txBox="1"/>
           <p:nvPr/>
         </p:nvSpPr>
@@ -2485,7 +2467,7 @@
       </p:sp>
       <p:sp>
         <p:nvSpPr>
-          <p:cNvPr id="56" name="마감 3주 전까지 주제 미확정"/>
+          <p:cNvPr id="55" name="마감 3주 전까지 주제 미확정"/>
           <p:cNvSpPr txBox="1"/>
           <p:nvPr/>
         </p:nvSpPr>
@@ -2524,7 +2506,7 @@
       </p:sp>
       <p:sp>
         <p:nvSpPr>
-          <p:cNvPr id="57" name="참신성"/>
+          <p:cNvPr id="56" name="참신성"/>
           <p:cNvSpPr txBox="1"/>
           <p:nvPr/>
         </p:nvSpPr>
@@ -2563,7 +2545,7 @@
       </p:sp>
       <p:sp>
         <p:nvSpPr>
-          <p:cNvPr id="58" name="구현 가능성"/>
+          <p:cNvPr id="57" name="구현 가능성"/>
           <p:cNvSpPr txBox="1"/>
           <p:nvPr/>
         </p:nvSpPr>
@@ -2602,7 +2584,7 @@
       </p:sp>
       <p:sp>
         <p:nvSpPr>
-          <p:cNvPr id="59" name="VS"/>
+          <p:cNvPr id="58" name="VS"/>
           <p:cNvSpPr txBox="1"/>
           <p:nvPr/>
         </p:nvSpPr>
@@ -2641,7 +2623,7 @@
       </p:sp>
       <p:sp>
         <p:nvSpPr>
-          <p:cNvPr id="60" name="경청 · 수상작 분석 · 교수님 조언"/>
+          <p:cNvPr id="59" name="경청 · 수상작 분석 · 교수님 조언"/>
           <p:cNvSpPr txBox="1"/>
           <p:nvPr/>
         </p:nvSpPr>
@@ -2680,7 +2662,7 @@
       </p:sp>
       <p:sp>
         <p:nvSpPr>
-          <p:cNvPr id="61" name="판단 기준 마련"/>
+          <p:cNvPr id="60" name="판단 기준 마련"/>
           <p:cNvSpPr txBox="1"/>
           <p:nvPr/>
         </p:nvSpPr>
@@ -2719,7 +2701,7 @@
       </p:sp>
       <p:sp>
         <p:nvSpPr>
-          <p:cNvPr id="62" name="‘유닛 모듈러 기반 사용자 맞춤형"/>
+          <p:cNvPr id="61" name="‘유닛 모듈러 기반 사용자 맞춤형"/>
           <p:cNvSpPr txBox="1"/>
           <p:nvPr/>
         </p:nvSpPr>
@@ -2758,7 +2740,7 @@
       </p:sp>
       <p:sp>
         <p:nvSpPr>
-          <p:cNvPr id="63" name="리모델링 방법’ 선정"/>
+          <p:cNvPr id="62" name="리모델링 방법’ 선정"/>
           <p:cNvSpPr txBox="1"/>
           <p:nvPr/>
         </p:nvSpPr>
@@ -2811,7 +2793,7 @@
       </p:sp>
       <p:sp>
         <p:nvSpPr>
-          <p:cNvPr id="64" name="리모델링 규모에 따라 유닛 모듈러를 배치하고,"/>
+          <p:cNvPr id="63" name="리모델링 규모에 따라 유닛 모듈러를 배치하고,"/>
           <p:cNvSpPr txBox="1"/>
           <p:nvPr/>
         </p:nvSpPr>
@@ -2850,7 +2832,7 @@
       </p:sp>
       <p:sp>
         <p:nvSpPr>
-          <p:cNvPr id="65" name="모듈 수 · 자재 물량을 자동 산출"/>
+          <p:cNvPr id="64" name="모듈 수 · 자재 물량을 자동 산출"/>
           <p:cNvSpPr txBox="1"/>
           <p:nvPr/>
         </p:nvSpPr>
@@ -2889,14 +2871,14 @@
       </p:sp>
       <p:sp>
         <p:nvSpPr>
-          <p:cNvPr id="66" name="팀장 · 나"/>
-          <p:cNvSpPr txBox="1"/>
-          <p:nvPr/>
-        </p:nvSpPr>
-        <p:spPr>
-          <a:xfrm>
-            <a:off x="6149578" y="2696964"/>
-            <a:ext cx="553045" cy="177800"/>
+          <p:cNvPr id="65" name="공동 목표"/>
+          <p:cNvSpPr txBox="1"/>
+          <p:nvPr/>
+        </p:nvSpPr>
+        <p:spPr>
+          <a:xfrm>
+            <a:off x="6047184" y="3902224"/>
+            <a:ext cx="605631" cy="177800"/>
           </a:xfrm>
           <a:prstGeom prst="rect">
             <a:avLst/>
@@ -2914,13 +2896,13 @@
             <a:r>
               <a:rPr lang="ko-KR" altLang="en-US" sz="1200" spc="-24" kern="0" dirty="0">
                 <a:solidFill>
-                  <a:srgbClr val="FFFFFF"/>
+                  <a:srgbClr val="004B8D"/>
                 </a:solidFill>
                 <a:latin typeface="Paperlogy 8 ExtraBold" pitchFamily="34" charset="0"/>
                 <a:ea typeface="Paperlogy 8 ExtraBold" pitchFamily="34" charset="-127"/>
                 <a:cs typeface="Paperlogy 8 ExtraBold" pitchFamily="34" charset="-120"/>
               </a:rPr>
-              <a:t>팀장 · 나</a:t>
+              <a:t>공동 목표</a:t>
             </a:r>
             <a:endParaRPr lang="en-US" sz="1200" dirty="0"/>
           </a:p>
@@ -2928,14 +2910,14 @@
       </p:sp>
       <p:sp>
         <p:nvSpPr>
-          <p:cNvPr id="67" name="프로젝트 총괄 ·"/>
-          <p:cNvSpPr txBox="1"/>
-          <p:nvPr/>
-        </p:nvSpPr>
-        <p:spPr>
-          <a:xfrm>
-            <a:off x="5882198" y="2926755"/>
-            <a:ext cx="935504" cy="177800"/>
+          <p:cNvPr id="66" name="3주 내 완성"/>
+          <p:cNvSpPr txBox="1"/>
+          <p:nvPr/>
+        </p:nvSpPr>
+        <p:spPr>
+          <a:xfrm>
+            <a:off x="6068120" y="4091434"/>
+            <a:ext cx="563662" cy="139700"/>
           </a:xfrm>
           <a:prstGeom prst="rect">
             <a:avLst/>
@@ -2951,7 +2933,124 @@
               <a:buNone/>
             </a:pPr>
             <a:r>
-              <a:rPr lang="ko-KR" altLang="en-US" sz="1200" spc="-30" kern="0" dirty="0">
+              <a:rPr lang="ko-KR" altLang="en-US" sz="900" spc="-18" kern="0" dirty="0">
+                <a:solidFill>
+                  <a:srgbClr val="4B5568"/>
+                </a:solidFill>
+                <a:latin typeface="Paperlogy 7 Bold" pitchFamily="34" charset="0"/>
+                <a:ea typeface="Paperlogy 7 Bold" pitchFamily="34" charset="-127"/>
+                <a:cs typeface="Paperlogy 7 Bold" pitchFamily="34" charset="-120"/>
+              </a:rPr>
+              <a:t>3주 내 완성</a:t>
+            </a:r>
+            <a:endParaRPr lang="en-US" sz="900" dirty="0"/>
+          </a:p>
+        </p:txBody>
+      </p:sp>
+      <p:sp>
+        <p:nvSpPr>
+          <p:cNvPr id="67" name="팀장"/>
+          <p:cNvSpPr txBox="1"/>
+          <p:nvPr/>
+        </p:nvSpPr>
+        <p:spPr>
+          <a:xfrm>
+            <a:off x="6149082" y="2586434"/>
+            <a:ext cx="312936" cy="177800"/>
+          </a:xfrm>
+          <a:prstGeom prst="rect">
+            <a:avLst/>
+          </a:prstGeom>
+          <a:noFill/>
+          <a:ln/>
+        </p:spPr>
+        <p:txBody>
+          <a:bodyPr wrap="none" lIns="0" tIns="0" rIns="0" bIns="0" rtlCol="0" anchor="ctr"/>
+          <a:lstStyle/>
+          <a:p>
+            <a:pPr algn="ctr" indent="0" marL="0">
+              <a:buNone/>
+            </a:pPr>
+            <a:r>
+              <a:rPr lang="ko-KR" altLang="en-US" sz="1200" spc="-24" kern="0" dirty="0">
+                <a:solidFill>
+                  <a:srgbClr val="FFFFFF"/>
+                </a:solidFill>
+                <a:latin typeface="Paperlogy 8 ExtraBold" pitchFamily="34" charset="0"/>
+                <a:ea typeface="Paperlogy 8 ExtraBold" pitchFamily="34" charset="-127"/>
+                <a:cs typeface="Paperlogy 8 ExtraBold" pitchFamily="34" charset="-120"/>
+              </a:rPr>
+              <a:t>팀장</a:t>
+            </a:r>
+            <a:endParaRPr lang="en-US" sz="1200" dirty="0"/>
+          </a:p>
+        </p:txBody>
+      </p:sp>
+      <p:sp>
+        <p:nvSpPr>
+          <p:cNvPr id="68" name="나"/>
+          <p:cNvSpPr txBox="1"/>
+          <p:nvPr/>
+        </p:nvSpPr>
+        <p:spPr>
+          <a:xfrm>
+            <a:off x="6514802" y="2607965"/>
+            <a:ext cx="148431" cy="139700"/>
+          </a:xfrm>
+          <a:prstGeom prst="rect">
+            <a:avLst/>
+          </a:prstGeom>
+          <a:noFill/>
+          <a:ln/>
+        </p:spPr>
+        <p:txBody>
+          <a:bodyPr wrap="none" lIns="0" tIns="0" rIns="0" bIns="0" rtlCol="0" anchor="ctr"/>
+          <a:lstStyle/>
+          <a:p>
+            <a:pPr algn="ctr" indent="0" marL="0">
+              <a:buNone/>
+            </a:pPr>
+            <a:r>
+              <a:rPr lang="ko-KR" altLang="en-US" sz="900" spc="-24" kern="0" dirty="0">
+                <a:solidFill>
+                  <a:srgbClr val="0B2147"/>
+                </a:solidFill>
+                <a:latin typeface="Paperlogy 8 ExtraBold" pitchFamily="34" charset="0"/>
+                <a:ea typeface="Paperlogy 8 ExtraBold" pitchFamily="34" charset="-127"/>
+                <a:cs typeface="Paperlogy 8 ExtraBold" pitchFamily="34" charset="-120"/>
+              </a:rPr>
+              <a:t>나</a:t>
+            </a:r>
+            <a:endParaRPr lang="en-US" sz="900" dirty="0"/>
+          </a:p>
+        </p:txBody>
+      </p:sp>
+      <p:sp>
+        <p:nvSpPr>
+          <p:cNvPr id="69" name="프로젝트 총괄 ·"/>
+          <p:cNvSpPr txBox="1"/>
+          <p:nvPr/>
+        </p:nvSpPr>
+        <p:spPr>
+          <a:xfrm>
+            <a:off x="5885777" y="2813745"/>
+            <a:ext cx="928247" cy="177800"/>
+          </a:xfrm>
+          <a:prstGeom prst="rect">
+            <a:avLst/>
+          </a:prstGeom>
+          <a:noFill/>
+          <a:ln/>
+        </p:spPr>
+        <p:txBody>
+          <a:bodyPr wrap="none" lIns="0" tIns="0" rIns="0" bIns="0" rtlCol="0" anchor="ctr"/>
+          <a:lstStyle/>
+          <a:p>
+            <a:pPr algn="ctr" indent="0" marL="0">
+              <a:buNone/>
+            </a:pPr>
+            <a:r>
+              <a:rPr lang="ko-KR" altLang="en-US" sz="1200" spc="-36" kern="0" dirty="0">
                 <a:solidFill>
                   <a:srgbClr val="DADEE3"/>
                 </a:solidFill>
@@ -2967,14 +3066,14 @@
       </p:sp>
       <p:sp>
         <p:nvSpPr>
-          <p:cNvPr id="68" name="Dynamo 기반 자동화 알고리즘 개발"/>
-          <p:cNvSpPr txBox="1"/>
-          <p:nvPr/>
-        </p:nvSpPr>
-        <p:spPr>
-          <a:xfrm>
-            <a:off x="5185750" y="3132435"/>
-            <a:ext cx="2328400" cy="177800"/>
+          <p:cNvPr id="70" name="Dynamo 기반"/>
+          <p:cNvSpPr txBox="1"/>
+          <p:nvPr/>
+        </p:nvSpPr>
+        <p:spPr>
+          <a:xfrm>
+            <a:off x="5858219" y="3004245"/>
+            <a:ext cx="983462" cy="177800"/>
           </a:xfrm>
           <a:prstGeom prst="rect">
             <a:avLst/>
@@ -2990,7 +3089,7 @@
               <a:buNone/>
             </a:pPr>
             <a:r>
-              <a:rPr lang="ko-KR" altLang="en-US" sz="1200" spc="-30" kern="0" dirty="0">
+              <a:rPr lang="ko-KR" altLang="en-US" sz="1200" spc="-36" kern="0" dirty="0">
                 <a:solidFill>
                   <a:srgbClr val="DADEE3"/>
                 </a:solidFill>
@@ -2998,7 +3097,7 @@
                 <a:ea typeface="Paperlogy 5 Medium" pitchFamily="34" charset="-127"/>
                 <a:cs typeface="Paperlogy 5 Medium" pitchFamily="34" charset="-120"/>
               </a:rPr>
-              <a:t>Dynamo 기반 자동화 알고리즘 개발</a:t>
+              <a:t>Dynamo 기반</a:t>
             </a:r>
             <a:endParaRPr lang="en-US" sz="1200" dirty="0"/>
           </a:p>
@@ -3006,13 +3105,52 @@
       </p:sp>
       <p:sp>
         <p:nvSpPr>
-          <p:cNvPr id="69" name="팀원 A"/>
-          <p:cNvSpPr txBox="1"/>
-          <p:nvPr/>
-        </p:nvSpPr>
-        <p:spPr>
-          <a:xfrm>
-            <a:off x="4854873" y="4068366"/>
+          <p:cNvPr id="71" name="자동화 알고리즘 개발"/>
+          <p:cNvSpPr txBox="1"/>
+          <p:nvPr/>
+        </p:nvSpPr>
+        <p:spPr>
+          <a:xfrm>
+            <a:off x="5701303" y="3194745"/>
+            <a:ext cx="1297295" cy="177800"/>
+          </a:xfrm>
+          <a:prstGeom prst="rect">
+            <a:avLst/>
+          </a:prstGeom>
+          <a:noFill/>
+          <a:ln/>
+        </p:spPr>
+        <p:txBody>
+          <a:bodyPr wrap="none" lIns="0" tIns="0" rIns="0" bIns="0" rtlCol="0" anchor="ctr"/>
+          <a:lstStyle/>
+          <a:p>
+            <a:pPr algn="ctr" indent="0" marL="0">
+              <a:buNone/>
+            </a:pPr>
+            <a:r>
+              <a:rPr lang="ko-KR" altLang="en-US" sz="1200" spc="-36" kern="0" dirty="0">
+                <a:solidFill>
+                  <a:srgbClr val="DADEE3"/>
+                </a:solidFill>
+                <a:latin typeface="Paperlogy 5 Medium" pitchFamily="34" charset="0"/>
+                <a:ea typeface="Paperlogy 5 Medium" pitchFamily="34" charset="-127"/>
+                <a:cs typeface="Paperlogy 5 Medium" pitchFamily="34" charset="-120"/>
+              </a:rPr>
+              <a:t>자동화 알고리즘 개발</a:t>
+            </a:r>
+            <a:endParaRPr lang="en-US" sz="1200" dirty="0"/>
+          </a:p>
+        </p:txBody>
+      </p:sp>
+      <p:sp>
+        <p:nvSpPr>
+          <p:cNvPr id="72" name="팀원 A"/>
+          <p:cNvSpPr txBox="1"/>
+          <p:nvPr/>
+        </p:nvSpPr>
+        <p:spPr>
+          <a:xfrm>
+            <a:off x="7473255" y="3767534"/>
             <a:ext cx="458589" cy="177800"/>
           </a:xfrm>
           <a:prstGeom prst="rect">
@@ -3045,14 +3183,14 @@
       </p:sp>
       <p:sp>
         <p:nvSpPr>
-          <p:cNvPr id="70" name="유닛 모듈러 설계 ·"/>
-          <p:cNvSpPr txBox="1"/>
-          <p:nvPr/>
-        </p:nvSpPr>
-        <p:spPr>
-          <a:xfrm>
-            <a:off x="4455394" y="4298156"/>
-            <a:ext cx="1105146" cy="177800"/>
+          <p:cNvPr id="73" name="유닛 모듈러 설계 ·"/>
+          <p:cNvSpPr txBox="1"/>
+          <p:nvPr/>
+        </p:nvSpPr>
+        <p:spPr>
+          <a:xfrm>
+            <a:off x="7078197" y="3994845"/>
+            <a:ext cx="1096206" cy="177800"/>
           </a:xfrm>
           <a:prstGeom prst="rect">
             <a:avLst/>
@@ -3068,7 +3206,7 @@
               <a:buNone/>
             </a:pPr>
             <a:r>
-              <a:rPr lang="ko-KR" altLang="en-US" sz="1200" spc="-30" kern="0" dirty="0">
+              <a:rPr lang="ko-KR" altLang="en-US" sz="1200" spc="-36" kern="0" dirty="0">
                 <a:solidFill>
                   <a:srgbClr val="4B5568"/>
                 </a:solidFill>
@@ -3084,14 +3222,14 @@
       </p:sp>
       <p:sp>
         <p:nvSpPr>
-          <p:cNvPr id="71" name="배치계획"/>
-          <p:cNvSpPr txBox="1"/>
-          <p:nvPr/>
-        </p:nvSpPr>
-        <p:spPr>
-          <a:xfrm>
-            <a:off x="4721920" y="4503837"/>
-            <a:ext cx="572095" cy="177800"/>
+          <p:cNvPr id="74" name="배치계획"/>
+          <p:cNvSpPr txBox="1"/>
+          <p:nvPr/>
+        </p:nvSpPr>
+        <p:spPr>
+          <a:xfrm>
+            <a:off x="7341791" y="4185345"/>
+            <a:ext cx="569020" cy="177800"/>
           </a:xfrm>
           <a:prstGeom prst="rect">
             <a:avLst/>
@@ -3107,7 +3245,7 @@
               <a:buNone/>
             </a:pPr>
             <a:r>
-              <a:rPr lang="ko-KR" altLang="en-US" sz="1200" spc="-30" kern="0" dirty="0">
+              <a:rPr lang="ko-KR" altLang="en-US" sz="1200" spc="-36" kern="0" dirty="0">
                 <a:solidFill>
                   <a:srgbClr val="4B5568"/>
                 </a:solidFill>
@@ -3123,13 +3261,13 @@
       </p:sp>
       <p:sp>
         <p:nvSpPr>
-          <p:cNvPr id="72" name="팀원 B"/>
-          <p:cNvSpPr txBox="1"/>
-          <p:nvPr/>
-        </p:nvSpPr>
-        <p:spPr>
-          <a:xfrm>
-            <a:off x="6196905" y="4068366"/>
+          <p:cNvPr id="75" name="팀원 B"/>
+          <p:cNvSpPr txBox="1"/>
+          <p:nvPr/>
+        </p:nvSpPr>
+        <p:spPr>
+          <a:xfrm>
+            <a:off x="6197005" y="4758134"/>
             <a:ext cx="458391" cy="177800"/>
           </a:xfrm>
           <a:prstGeom prst="rect">
@@ -3162,14 +3300,14 @@
       </p:sp>
       <p:sp>
         <p:nvSpPr>
-          <p:cNvPr id="73" name="Revit 기반"/>
-          <p:cNvSpPr txBox="1"/>
-          <p:nvPr/>
-        </p:nvSpPr>
-        <p:spPr>
-          <a:xfrm>
-            <a:off x="5992912" y="4298156"/>
-            <a:ext cx="713978" cy="177800"/>
+          <p:cNvPr id="76" name="Revit 기반"/>
+          <p:cNvSpPr txBox="1"/>
+          <p:nvPr/>
+        </p:nvSpPr>
+        <p:spPr>
+          <a:xfrm>
+            <a:off x="5995987" y="4985445"/>
+            <a:ext cx="707827" cy="177800"/>
           </a:xfrm>
           <a:prstGeom prst="rect">
             <a:avLst/>
@@ -3185,7 +3323,7 @@
               <a:buNone/>
             </a:pPr>
             <a:r>
-              <a:rPr lang="ko-KR" altLang="en-US" sz="1200" spc="-30" kern="0" dirty="0">
+              <a:rPr lang="ko-KR" altLang="en-US" sz="1200" spc="-36" kern="0" dirty="0">
                 <a:solidFill>
                   <a:srgbClr val="4B5568"/>
                 </a:solidFill>
@@ -3201,14 +3339,14 @@
       </p:sp>
       <p:sp>
         <p:nvSpPr>
-          <p:cNvPr id="74" name="BIM 모델링 ·"/>
-          <p:cNvSpPr txBox="1"/>
-          <p:nvPr/>
-        </p:nvSpPr>
-        <p:spPr>
-          <a:xfrm>
-            <a:off x="5930404" y="4503837"/>
-            <a:ext cx="838994" cy="177800"/>
+          <p:cNvPr id="77" name="BIM 모델링 ·"/>
+          <p:cNvSpPr txBox="1"/>
+          <p:nvPr/>
+        </p:nvSpPr>
+        <p:spPr>
+          <a:xfrm>
+            <a:off x="5933877" y="5175945"/>
+            <a:ext cx="832148" cy="177800"/>
           </a:xfrm>
           <a:prstGeom prst="rect">
             <a:avLst/>
@@ -3224,7 +3362,7 @@
               <a:buNone/>
             </a:pPr>
             <a:r>
-              <a:rPr lang="ko-KR" altLang="en-US" sz="1200" spc="-30" kern="0" dirty="0">
+              <a:rPr lang="ko-KR" altLang="en-US" sz="1200" spc="-36" kern="0" dirty="0">
                 <a:solidFill>
                   <a:srgbClr val="4B5568"/>
                 </a:solidFill>
@@ -3240,14 +3378,14 @@
       </p:sp>
       <p:sp>
         <p:nvSpPr>
-          <p:cNvPr id="75" name="데이터 구축"/>
-          <p:cNvSpPr txBox="1"/>
-          <p:nvPr/>
-        </p:nvSpPr>
-        <p:spPr>
-          <a:xfrm>
-            <a:off x="5983883" y="4709517"/>
-            <a:ext cx="732036" cy="177800"/>
+          <p:cNvPr id="78" name="데이터 구축"/>
+          <p:cNvSpPr txBox="1"/>
+          <p:nvPr/>
+        </p:nvSpPr>
+        <p:spPr>
+          <a:xfrm>
+            <a:off x="5986165" y="5366445"/>
+            <a:ext cx="727472" cy="177800"/>
           </a:xfrm>
           <a:prstGeom prst="rect">
             <a:avLst/>
@@ -3263,7 +3401,7 @@
               <a:buNone/>
             </a:pPr>
             <a:r>
-              <a:rPr lang="ko-KR" altLang="en-US" sz="1200" spc="-30" kern="0" dirty="0">
+              <a:rPr lang="ko-KR" altLang="en-US" sz="1200" spc="-36" kern="0" dirty="0">
                 <a:solidFill>
                   <a:srgbClr val="4B5568"/>
                 </a:solidFill>
@@ -3279,13 +3417,13 @@
       </p:sp>
       <p:sp>
         <p:nvSpPr>
-          <p:cNvPr id="76" name="팀원 C"/>
-          <p:cNvSpPr txBox="1"/>
-          <p:nvPr/>
-        </p:nvSpPr>
-        <p:spPr>
-          <a:xfrm>
-            <a:off x="7541419" y="4068366"/>
+          <p:cNvPr id="79" name="팀원 C"/>
+          <p:cNvSpPr txBox="1"/>
+          <p:nvPr/>
+        </p:nvSpPr>
+        <p:spPr>
+          <a:xfrm>
+            <a:off x="4923234" y="3672284"/>
             <a:ext cx="453231" cy="177800"/>
           </a:xfrm>
           <a:prstGeom prst="rect">
@@ -3318,14 +3456,14 @@
       </p:sp>
       <p:sp>
         <p:nvSpPr>
-          <p:cNvPr id="77" name="리모델링 적용"/>
-          <p:cNvSpPr txBox="1"/>
-          <p:nvPr/>
-        </p:nvSpPr>
-        <p:spPr>
-          <a:xfrm>
-            <a:off x="7260630" y="4298156"/>
-            <a:ext cx="862409" cy="177800"/>
+          <p:cNvPr id="80" name="리모델링 적용"/>
+          <p:cNvSpPr txBox="1"/>
+          <p:nvPr/>
+        </p:nvSpPr>
+        <p:spPr>
+          <a:xfrm>
+            <a:off x="4645124" y="3899595"/>
+            <a:ext cx="857052" cy="177800"/>
           </a:xfrm>
           <a:prstGeom prst="rect">
             <a:avLst/>
@@ -3341,7 +3479,7 @@
               <a:buNone/>
             </a:pPr>
             <a:r>
-              <a:rPr lang="ko-KR" altLang="en-US" sz="1200" spc="-30" kern="0" dirty="0">
+              <a:rPr lang="ko-KR" altLang="en-US" sz="1200" spc="-36" kern="0" dirty="0">
                 <a:solidFill>
                   <a:srgbClr val="4B5568"/>
                 </a:solidFill>
@@ -3357,14 +3495,14 @@
       </p:sp>
       <p:sp>
         <p:nvSpPr>
-          <p:cNvPr id="78" name="시나리오 구성 ·"/>
-          <p:cNvSpPr txBox="1"/>
-          <p:nvPr/>
-        </p:nvSpPr>
-        <p:spPr>
-          <a:xfrm>
-            <a:off x="7224132" y="4503837"/>
-            <a:ext cx="935504" cy="177800"/>
+          <p:cNvPr id="81" name="시나리오 구성 ·"/>
+          <p:cNvSpPr txBox="1"/>
+          <p:nvPr/>
+        </p:nvSpPr>
+        <p:spPr>
+          <a:xfrm>
+            <a:off x="4609527" y="4090095"/>
+            <a:ext cx="928247" cy="177800"/>
           </a:xfrm>
           <a:prstGeom prst="rect">
             <a:avLst/>
@@ -3380,7 +3518,7 @@
               <a:buNone/>
             </a:pPr>
             <a:r>
-              <a:rPr lang="ko-KR" altLang="en-US" sz="1200" spc="-30" kern="0" dirty="0">
+              <a:rPr lang="ko-KR" altLang="en-US" sz="1200" spc="-36" kern="0" dirty="0">
                 <a:solidFill>
                   <a:srgbClr val="4B5568"/>
                 </a:solidFill>
@@ -3396,14 +3534,14 @@
       </p:sp>
       <p:sp>
         <p:nvSpPr>
-          <p:cNvPr id="79" name="시연 영상 제작"/>
-          <p:cNvSpPr txBox="1"/>
-          <p:nvPr/>
-        </p:nvSpPr>
-        <p:spPr>
-          <a:xfrm>
-            <a:off x="7245846" y="4709517"/>
-            <a:ext cx="892076" cy="177800"/>
+          <p:cNvPr id="82" name="시연 영상 제작"/>
+          <p:cNvSpPr txBox="1"/>
+          <p:nvPr/>
+        </p:nvSpPr>
+        <p:spPr>
+          <a:xfrm>
+            <a:off x="4630638" y="4280595"/>
+            <a:ext cx="886023" cy="177800"/>
           </a:xfrm>
           <a:prstGeom prst="rect">
             <a:avLst/>
@@ -3419,7 +3557,7 @@
               <a:buNone/>
             </a:pPr>
             <a:r>
-              <a:rPr lang="ko-KR" altLang="en-US" sz="1200" spc="-30" kern="0" dirty="0">
+              <a:rPr lang="ko-KR" altLang="en-US" sz="1200" spc="-36" kern="0" dirty="0">
                 <a:solidFill>
                   <a:srgbClr val="4B5568"/>
                 </a:solidFill>
@@ -3435,30 +3573,30 @@
       </p:sp>
       <p:sp>
         <p:nvSpPr>
-          <p:cNvPr id="80" name="이틀마다 진행상황 공유 · 피드백"/>
-          <p:cNvSpPr txBox="1"/>
-          <p:nvPr/>
-        </p:nvSpPr>
-        <p:spPr>
-          <a:xfrm>
-            <a:off x="5528370" y="5304234"/>
-            <a:ext cx="1984173" cy="177800"/>
-          </a:xfrm>
-          <a:prstGeom prst="rect">
-            <a:avLst/>
-          </a:prstGeom>
-          <a:noFill/>
-          <a:ln/>
-        </p:spPr>
-        <p:txBody>
-          <a:bodyPr wrap="none" lIns="0" tIns="0" rIns="0" bIns="0" rtlCol="0" anchor="ctr"/>
-          <a:lstStyle/>
-          <a:p>
-            <a:pPr algn="l" indent="0" marL="0">
-              <a:buNone/>
-            </a:pPr>
-            <a:r>
-              <a:rPr lang="ko-KR" altLang="en-US" sz="1200" spc="-24" kern="0" dirty="0">
+          <p:cNvPr id="83" name="이틀마다 진행상황"/>
+          <p:cNvSpPr txBox="1"/>
+          <p:nvPr/>
+        </p:nvSpPr>
+        <p:spPr>
+          <a:xfrm>
+            <a:off x="7212023" y="4817864"/>
+            <a:ext cx="953173" cy="152400"/>
+          </a:xfrm>
+          <a:prstGeom prst="rect">
+            <a:avLst/>
+          </a:prstGeom>
+          <a:noFill/>
+          <a:ln/>
+        </p:spPr>
+        <p:txBody>
+          <a:bodyPr wrap="none" lIns="0" tIns="0" rIns="0" bIns="0" rtlCol="0" anchor="ctr"/>
+          <a:lstStyle/>
+          <a:p>
+            <a:pPr algn="ctr" indent="0" marL="0">
+              <a:buNone/>
+            </a:pPr>
+            <a:r>
+              <a:rPr lang="ko-KR" altLang="en-US" sz="1000" spc="-20" kern="0" dirty="0">
                 <a:solidFill>
                   <a:srgbClr val="0B2147"/>
                 </a:solidFill>
@@ -3466,15 +3604,54 @@
                 <a:ea typeface="Paperlogy 7 Bold" pitchFamily="34" charset="-127"/>
                 <a:cs typeface="Paperlogy 7 Bold" pitchFamily="34" charset="-120"/>
               </a:rPr>
-              <a:t>이틀마다 진행상황 공유 · 피드백</a:t>
-            </a:r>
-            <a:endParaRPr lang="en-US" sz="1200" dirty="0"/>
-          </a:p>
-        </p:txBody>
-      </p:sp>
-      <p:sp>
-        <p:nvSpPr>
-          <p:cNvPr id="81" name="리모델링 앱 개발 아이디어 시연 영상"/>
+              <a:t>이틀마다 진행상황</a:t>
+            </a:r>
+            <a:endParaRPr lang="en-US" sz="1000" dirty="0"/>
+          </a:p>
+        </p:txBody>
+      </p:sp>
+      <p:sp>
+        <p:nvSpPr>
+          <p:cNvPr id="84" name="공유 · 피드백"/>
+          <p:cNvSpPr txBox="1"/>
+          <p:nvPr/>
+        </p:nvSpPr>
+        <p:spPr>
+          <a:xfrm>
+            <a:off x="7345561" y="4982964"/>
+            <a:ext cx="686098" cy="152400"/>
+          </a:xfrm>
+          <a:prstGeom prst="rect">
+            <a:avLst/>
+          </a:prstGeom>
+          <a:noFill/>
+          <a:ln/>
+        </p:spPr>
+        <p:txBody>
+          <a:bodyPr wrap="none" lIns="0" tIns="0" rIns="0" bIns="0" rtlCol="0" anchor="ctr"/>
+          <a:lstStyle/>
+          <a:p>
+            <a:pPr algn="ctr" indent="0" marL="0">
+              <a:buNone/>
+            </a:pPr>
+            <a:r>
+              <a:rPr lang="ko-KR" altLang="en-US" sz="1000" spc="-20" kern="0" dirty="0">
+                <a:solidFill>
+                  <a:srgbClr val="0B2147"/>
+                </a:solidFill>
+                <a:latin typeface="Paperlogy 7 Bold" pitchFamily="34" charset="0"/>
+                <a:ea typeface="Paperlogy 7 Bold" pitchFamily="34" charset="-127"/>
+                <a:cs typeface="Paperlogy 7 Bold" pitchFamily="34" charset="-120"/>
+              </a:rPr>
+              <a:t>공유 · 피드백</a:t>
+            </a:r>
+            <a:endParaRPr lang="en-US" sz="1000" dirty="0"/>
+          </a:p>
+        </p:txBody>
+      </p:sp>
+      <p:sp>
+        <p:nvSpPr>
+          <p:cNvPr id="85" name="리모델링 앱 개발 아이디어 시연 영상"/>
           <p:cNvSpPr txBox="1"/>
           <p:nvPr/>
         </p:nvSpPr>
@@ -3513,7 +3690,7 @@
       </p:sp>
       <p:sp>
         <p:nvSpPr>
-          <p:cNvPr id="82" name="장려상"/>
+          <p:cNvPr id="86" name="장려상"/>
           <p:cNvSpPr txBox="1"/>
           <p:nvPr/>
         </p:nvSpPr>
@@ -3552,7 +3729,7 @@
       </p:sp>
       <p:sp>
         <p:nvSpPr>
-          <p:cNvPr id="83" name="학생 BIM 경진대회 장려상 · 남은 3주 내 완성"/>
+          <p:cNvPr id="87" name="학생 BIM 경진대회 장려상 · 남은 3주 내 완성"/>
           <p:cNvSpPr txBox="1"/>
           <p:nvPr/>
         </p:nvSpPr>
@@ -3591,7 +3768,7 @@
       </p:sp>
       <p:sp>
         <p:nvSpPr>
-          <p:cNvPr id="84" name="KEY MESSAGE"/>
+          <p:cNvPr id="88" name="KEY MESSAGE"/>
           <p:cNvSpPr txBox="1"/>
           <p:nvPr/>
         </p:nvSpPr>
@@ -3630,7 +3807,7 @@
       </p:sp>
       <p:sp>
         <p:nvSpPr>
-          <p:cNvPr id="85" name="서로 다른 사람을 하나의 공동 목표로 연결합니다"/>
+          <p:cNvPr id="89" name="서로 다른 사람을 하나의 공동 목표로 연결합니다"/>
           <p:cNvSpPr txBox="1"/>
           <p:nvPr/>
         </p:nvSpPr>
@@ -3697,7 +3874,7 @@
       </p:sp>
       <p:sp>
         <p:nvSpPr>
-          <p:cNvPr id="86" name="2026년 하반기 신입사원 공개채용"/>
+          <p:cNvPr id="90" name="2026년 하반기 신입사원 공개채용"/>
           <p:cNvSpPr txBox="1"/>
           <p:nvPr/>
         </p:nvSpPr>
@@ -3736,7 +3913,7 @@
       </p:sp>
       <p:sp>
         <p:nvSpPr>
-          <p:cNvPr id="87" name="01 / 03"/>
+          <p:cNvPr id="91" name="01 / 03"/>
           <p:cNvSpPr txBox="1"/>
           <p:nvPr/>
         </p:nvSpPr>

</xml_diff>